<commit_message>
Deck follows the shortened script: new order, closing, and link
Order now tracks the script: cover, the gap, what Noéa does, "built to be universal", the two layers, machine learning, the closing. The universal idea moves ahead of the layers and the data, as asked.

The gap slide is a single statement instead of a three-column diagram, and the universal slide is a ruled list instead of three columns, so slides no longer repeat each other's layout or content. "XR and sound" becomes "XR experience" and "Science layer" becomes "Diagnostic layer", matching the script; the curatorial layer is described as currently kept separate, so the feeling could be redesigned.

The closing is rewritten around the new ending (machine intelligence connected to natural intelligence; human response tested in human labs with HCI methods) and the three-question list is dropped. The link at the end is now meetingofwaters.org/noea.

Co-Authored-By: Claude Sonnet 5.5 <noreply@anthropic.com>
</commit_message>
<xml_diff>
--- a/docs/noea-introduction-animated.pptx
+++ b/docs/noea-introduction-animated.pptx
@@ -648,7 +648,7 @@
           <a:lstStyle/>
           <a:p>
             <a:r>
-              <a:t>Noéa reads a rainfall or river record the way a cardiologist reads an ECG, looking for rhythm, memory and shock. From that it derives two affective values, valence and arousal: how pleasant or distressing, and how activated. Those are designed to feed an XR and sound experience.</a:t>
+              <a:t>Noéa translates hydrological records into something people can experience. It reads a rainfall or river record the way a cardiologist reads an ECG, looking for rhythm, memory and shock. From that it derives two affective values, valence and arousal: how pleasant or distressing, and how activated. Those are designed to feed into an XR experience.</a:t>
             </a:r>
           </a:p>
         </p:txBody>
@@ -718,7 +718,7 @@
           <a:lstStyle/>
           <a:p>
             <a:r>
-              <a:t>There are two layers, kept deliberately apart. The first is plain science: it measures what happened. For Hong Kong, over a century of daily rainfall from the Observatory; for the Rhine and its alpine tributaries, eight stations of discharge. The second layer is curatorial: it decides what a drought or a flood should feel like, how alarming or how heavy. It is kept separate from the measurements, so the feeling can be redesigned without changing any of the science.</a:t>
+              <a:t>Our method is built to be universal, where each record fits its own model on its own history. Public records of Hong Kong and the Rhine are the two we've tested. And another rainfall or river record can go through the same pipeline.</a:t>
             </a:r>
           </a:p>
         </p:txBody>
@@ -788,7 +788,7 @@
           <a:lstStyle/>
           <a:p>
             <a:r>
-              <a:t>Machine learning has one job so far: finding unusual years. For each record, an unsupervised model learns what a typical year looks like, then scores how badly each year fails to fit. On the Rhine, its highest-scoring years include the August 2005 Alpine flood, the May 1999 Swiss flood, and the Christmas 1993 flood. It was never told those events existed.</a:t>
+              <a:t>There are two layers, kept deliberately apart. The first diagnostic layer is plain science: for Hong Kong, over a century of daily rainfall; for the Rhine and its alpine tributaries, eight stations of discharge. The second layer is curatorial, which is currently kept separate from the measurements, so the feeling would be redesigned without changing any of the science.</a:t>
             </a:r>
           </a:p>
         </p:txBody>
@@ -858,7 +858,7 @@
           <a:lstStyle/>
           <a:p>
             <a:r>
-              <a:t>The method isn't specific to these places. Each record fits its own model on its own history, so another rainfall or river record can go through the same pipeline. Hong Kong and the Rhine are the two I've tested.</a:t>
+              <a:t>Machine learning has one job so far: finding unusual years. For each record, an unsupervised model learns what a typical year looks like, then scores how badly each year fails to fit.</a:t>
             </a:r>
           </a:p>
         </p:txBody>
@@ -928,7 +928,7 @@
           <a:lstStyle/>
           <a:p>
             <a:r>
-              <a:t>The model's output is a score, not a feeling. What a flagged year should feel like, and whether people actually feel it, comes from people, not from the model. So the real result is how people respond: whether they perceive what the system intends, whether they understand what a flag, or a missing flag, means, and whether it helps the people who have to decide. That is the research, and nobody has tested it yet.</a:t>
+              <a:t>Noéa connects machine intelligence to natural intelligence: a model learns the rhythm of a river or rainfall record and flags when it breaks. How people respond to that now has to be tested in human labs, with HCI methods. That is the research.</a:t>
             </a:r>
           </a:p>
         </p:txBody>
@@ -4368,8 +4368,8 @@
         </p:nvSpPr>
         <p:spPr>
           <a:xfrm>
-            <a:off x="914400" y="685800"/>
-            <a:ext cx="10362895" cy="1371600"/>
+            <a:off x="914400" y="2011680"/>
+            <a:ext cx="10362895" cy="2194560"/>
           </a:xfrm>
           <a:prstGeom prst="rect">
             <a:avLst/>
@@ -4384,11 +4384,11 @@
           <a:p>
             <a:pPr algn="l">
               <a:lnSpc>
-                <a:spcPct val="105000"/>
+                <a:spcPct val="110000"/>
               </a:lnSpc>
             </a:pPr>
             <a:r>
-              <a:rPr sz="3360" b="0" i="0">
+              <a:rPr sz="3860" b="0" i="0">
                 <a:solidFill>
                   <a:srgbClr val="111A20"/>
                 </a:solidFill>
@@ -4407,15 +4407,15 @@
         </p:nvCxnSpPr>
         <p:spPr>
           <a:xfrm>
-            <a:off x="914400" y="3246120"/>
-            <a:ext cx="3200400" cy="0"/>
+            <a:off x="914400" y="4206240"/>
+            <a:ext cx="1097280" cy="0"/>
           </a:xfrm>
           <a:prstGeom prst="line">
             <a:avLst/>
           </a:prstGeom>
-          <a:ln w="15875">
+          <a:ln w="38100">
             <a:solidFill>
-              <a:srgbClr val="D3DDE2"/>
+              <a:srgbClr val="00526F"/>
             </a:solidFill>
           </a:ln>
         </p:spPr>
@@ -4442,8 +4442,8 @@
         </p:nvSpPr>
         <p:spPr>
           <a:xfrm>
-            <a:off x="914400" y="3520439"/>
-            <a:ext cx="3200400" cy="274320"/>
+            <a:off x="914400" y="4434840"/>
+            <a:ext cx="10362895" cy="914400"/>
           </a:xfrm>
           <a:prstGeom prst="rect">
             <a:avLst/>
@@ -4456,314 +4456,26 @@
           </a:bodyPr>
           <a:lstStyle/>
           <a:p>
-            <a:pPr algn="l"/>
-            <a:r>
-              <a:rPr sz="1010" b="1" i="0" spc="140">
-                <a:solidFill>
-                  <a:srgbClr val="5F6F78"/>
-                </a:solidFill>
-                <a:latin typeface="Frutiger"/>
-              </a:rPr>
-              <a:t>DETECT</a:t>
-            </a:r>
-          </a:p>
-        </p:txBody>
-      </p:sp>
-      <p:sp>
-        <p:nvSpPr>
-          <p:cNvPr id="5" name="TextBox 4"/>
-          <p:cNvSpPr txBox="1"/>
-          <p:nvPr/>
-        </p:nvSpPr>
-        <p:spPr>
-          <a:xfrm>
-            <a:off x="914400" y="4023359"/>
-            <a:ext cx="3017520" cy="1463040"/>
-          </a:xfrm>
-          <a:prstGeom prst="rect">
-            <a:avLst/>
-          </a:prstGeom>
-          <a:noFill/>
-        </p:spPr>
-        <p:txBody>
-          <a:bodyPr wrap="square" lIns="0" rIns="0" tIns="0" bIns="0" anchor="t">
-            <a:noAutofit/>
-          </a:bodyPr>
-          <a:lstStyle/>
-          <a:p>
             <a:pPr algn="l">
               <a:lnSpc>
-                <a:spcPct val="112000"/>
+                <a:spcPct val="115000"/>
               </a:lnSpc>
             </a:pPr>
             <a:r>
-              <a:rPr sz="2020" b="0" i="0">
-                <a:solidFill>
-                  <a:srgbClr val="111A20"/>
+              <a:rPr sz="1850" b="0" i="1">
+                <a:solidFill>
+                  <a:srgbClr val="00526F"/>
                 </a:solidFill>
                 <a:latin typeface="Athelas"/>
               </a:rPr>
-              <a:t>Stations now measure rainfall, rivers and glaciers at scale.</a:t>
-            </a:r>
-          </a:p>
-        </p:txBody>
-      </p:sp>
-      <p:cxnSp>
-        <p:nvCxnSpPr>
-          <p:cNvPr id="6" name="Connector 5"/>
-          <p:cNvCxnSpPr/>
-          <p:nvPr/>
-        </p:nvCxnSpPr>
-        <p:spPr>
-          <a:xfrm>
-            <a:off x="4494276" y="3246120"/>
-            <a:ext cx="3200399" cy="0"/>
-          </a:xfrm>
-          <a:prstGeom prst="line">
-            <a:avLst/>
-          </a:prstGeom>
-          <a:ln w="38100">
-            <a:solidFill>
-              <a:srgbClr val="00526F"/>
-            </a:solidFill>
-          </a:ln>
-        </p:spPr>
-        <p:style>
-          <a:lnRef idx="2">
-            <a:schemeClr val="accent1"/>
-          </a:lnRef>
-          <a:fillRef idx="0">
-            <a:schemeClr val="accent1"/>
-          </a:fillRef>
-          <a:effectRef idx="1">
-            <a:schemeClr val="accent1"/>
-          </a:effectRef>
-          <a:fontRef idx="minor">
-            <a:schemeClr val="tx1"/>
-          </a:fontRef>
-        </p:style>
-      </p:cxnSp>
-      <p:sp>
-        <p:nvSpPr>
-          <p:cNvPr id="7" name="TextBox 6"/>
-          <p:cNvSpPr txBox="1"/>
-          <p:nvPr/>
-        </p:nvSpPr>
-        <p:spPr>
-          <a:xfrm>
-            <a:off x="4494276" y="3520439"/>
-            <a:ext cx="3200400" cy="274320"/>
-          </a:xfrm>
-          <a:prstGeom prst="rect">
-            <a:avLst/>
-          </a:prstGeom>
-          <a:noFill/>
-        </p:spPr>
-        <p:txBody>
-          <a:bodyPr wrap="square" lIns="0" rIns="0" tIns="0" bIns="0" anchor="t">
-            <a:noAutofit/>
-          </a:bodyPr>
-          <a:lstStyle/>
-          <a:p>
-            <a:pPr algn="l"/>
-            <a:r>
-              <a:rPr sz="1010" b="1" i="0" spc="140">
-                <a:solidFill>
-                  <a:srgbClr val="00526F"/>
-                </a:solidFill>
-                <a:latin typeface="Frutiger"/>
-              </a:rPr>
-              <a:t>THE MISSING LAYER</a:t>
-            </a:r>
-          </a:p>
-        </p:txBody>
-      </p:sp>
-      <p:sp>
-        <p:nvSpPr>
-          <p:cNvPr id="8" name="TextBox 7"/>
-          <p:cNvSpPr txBox="1"/>
-          <p:nvPr/>
-        </p:nvSpPr>
-        <p:spPr>
-          <a:xfrm>
-            <a:off x="4494276" y="4023359"/>
-            <a:ext cx="3017520" cy="1463040"/>
-          </a:xfrm>
-          <a:prstGeom prst="rect">
-            <a:avLst/>
-          </a:prstGeom>
-          <a:noFill/>
-        </p:spPr>
-        <p:txBody>
-          <a:bodyPr wrap="square" lIns="0" rIns="0" tIns="0" bIns="0" anchor="t">
-            <a:noAutofit/>
-          </a:bodyPr>
-          <a:lstStyle/>
-          <a:p>
-            <a:pPr algn="l">
-              <a:lnSpc>
-                <a:spcPct val="112000"/>
-              </a:lnSpc>
-            </a:pPr>
-            <a:r>
-              <a:rPr sz="2020" b="0" i="0">
-                <a:solidFill>
-                  <a:srgbClr val="111A20"/>
-                </a:solidFill>
-                <a:latin typeface="Athelas"/>
-              </a:rPr>
-              <a:t>Turning measurement into meaning people can experience.</a:t>
-            </a:r>
-          </a:p>
-        </p:txBody>
-      </p:sp>
-      <p:cxnSp>
-        <p:nvCxnSpPr>
-          <p:cNvPr id="9" name="Connector 8"/>
-          <p:cNvCxnSpPr/>
-          <p:nvPr/>
-        </p:nvCxnSpPr>
-        <p:spPr>
-          <a:xfrm>
-            <a:off x="8074152" y="3246120"/>
-            <a:ext cx="3200400" cy="0"/>
-          </a:xfrm>
-          <a:prstGeom prst="line">
-            <a:avLst/>
-          </a:prstGeom>
-          <a:ln w="15875">
-            <a:solidFill>
-              <a:srgbClr val="D3DDE2"/>
-            </a:solidFill>
-          </a:ln>
-        </p:spPr>
-        <p:style>
-          <a:lnRef idx="2">
-            <a:schemeClr val="accent1"/>
-          </a:lnRef>
-          <a:fillRef idx="0">
-            <a:schemeClr val="accent1"/>
-          </a:fillRef>
-          <a:effectRef idx="1">
-            <a:schemeClr val="accent1"/>
-          </a:effectRef>
-          <a:fontRef idx="minor">
-            <a:schemeClr val="tx1"/>
-          </a:fontRef>
-        </p:style>
-      </p:cxnSp>
-      <p:sp>
-        <p:nvSpPr>
-          <p:cNvPr id="10" name="TextBox 9"/>
-          <p:cNvSpPr txBox="1"/>
-          <p:nvPr/>
-        </p:nvSpPr>
-        <p:spPr>
-          <a:xfrm>
-            <a:off x="8074152" y="3520439"/>
-            <a:ext cx="3200400" cy="274320"/>
-          </a:xfrm>
-          <a:prstGeom prst="rect">
-            <a:avLst/>
-          </a:prstGeom>
-          <a:noFill/>
-        </p:spPr>
-        <p:txBody>
-          <a:bodyPr wrap="square" lIns="0" rIns="0" tIns="0" bIns="0" anchor="t">
-            <a:noAutofit/>
-          </a:bodyPr>
-          <a:lstStyle/>
-          <a:p>
-            <a:pPr algn="l"/>
-            <a:r>
-              <a:rPr sz="1010" b="1" i="0" spc="140">
-                <a:solidFill>
-                  <a:srgbClr val="5F6F78"/>
-                </a:solidFill>
-                <a:latin typeface="Frutiger"/>
-              </a:rPr>
-              <a:t>RESPOND</a:t>
-            </a:r>
-          </a:p>
-        </p:txBody>
-      </p:sp>
-      <p:sp>
-        <p:nvSpPr>
-          <p:cNvPr id="11" name="TextBox 10"/>
-          <p:cNvSpPr txBox="1"/>
-          <p:nvPr/>
-        </p:nvSpPr>
-        <p:spPr>
-          <a:xfrm>
-            <a:off x="8074152" y="4023359"/>
-            <a:ext cx="3017520" cy="1463040"/>
-          </a:xfrm>
-          <a:prstGeom prst="rect">
-            <a:avLst/>
-          </a:prstGeom>
-          <a:noFill/>
-        </p:spPr>
-        <p:txBody>
-          <a:bodyPr wrap="square" lIns="0" rIns="0" tIns="0" bIns="0" anchor="t">
-            <a:noAutofit/>
-          </a:bodyPr>
-          <a:lstStyle/>
-          <a:p>
-            <a:pPr algn="l">
-              <a:lnSpc>
-                <a:spcPct val="112000"/>
-              </a:lnSpc>
-            </a:pPr>
-            <a:r>
-              <a:rPr sz="2020" b="0" i="0">
-                <a:solidFill>
-                  <a:srgbClr val="111A20"/>
-                </a:solidFill>
-                <a:latin typeface="Athelas"/>
-              </a:rPr>
-              <a:t>Decisions stall between knowing and acting.</a:t>
-            </a:r>
-          </a:p>
-        </p:txBody>
-      </p:sp>
-      <p:sp>
-        <p:nvSpPr>
-          <p:cNvPr id="12" name="TextBox 11"/>
-          <p:cNvSpPr txBox="1"/>
-          <p:nvPr/>
-        </p:nvSpPr>
-        <p:spPr>
-          <a:xfrm>
-            <a:off x="4494276" y="5349240"/>
-            <a:ext cx="3200400" cy="365760"/>
-          </a:xfrm>
-          <a:prstGeom prst="rect">
-            <a:avLst/>
-          </a:prstGeom>
-          <a:noFill/>
-        </p:spPr>
-        <p:txBody>
-          <a:bodyPr wrap="square" lIns="0" rIns="0" tIns="0" bIns="0" anchor="t">
-            <a:noAutofit/>
-          </a:bodyPr>
-          <a:lstStyle/>
-          <a:p>
-            <a:pPr algn="l"/>
-            <a:r>
-              <a:rPr sz="1340" b="1" i="0">
-                <a:solidFill>
-                  <a:srgbClr val="00526F"/>
-                </a:solidFill>
-                <a:latin typeface="Frutiger"/>
-              </a:rPr>
-              <a:t>Noéa works in the middle.</a:t>
+              <a:t>Noéa works in the missing layer: turning measurement into meaning people can experience.</a:t>
             </a:r>
           </a:p>
         </p:txBody>
       </p:sp>
       <p:pic>
         <p:nvPicPr>
-          <p:cNvPr id="13" name="Picture 12" descr="logo.png"/>
+          <p:cNvPr id="5" name="Picture 4" descr="logo.png"/>
           <p:cNvPicPr>
             <a:picLocks noChangeAspect="1"/>
           </p:cNvPicPr>
@@ -4787,7 +4499,7 @@
       </p:pic>
       <p:sp>
         <p:nvSpPr>
-          <p:cNvPr id="14" name="TextBox 13"/>
+          <p:cNvPr id="6" name="TextBox 5"/>
           <p:cNvSpPr txBox="1"/>
           <p:nvPr/>
         </p:nvSpPr>
@@ -5480,7 +5192,7 @@
                 </a:solidFill>
                 <a:latin typeface="Athelas"/>
               </a:rPr>
-              <a:t>XR and sound</a:t>
+              <a:t>XR experience</a:t>
             </a:r>
           </a:p>
         </p:txBody>
@@ -5522,7 +5234,7 @@
                 </a:solidFill>
                 <a:latin typeface="Frutiger"/>
               </a:rPr>
-              <a:t>Designed to feed immersive and sonic experiences. The output format is still provisional.</a:t>
+              <a:t>Designed to feed an immersive XR experience. The output format is still provisional.</a:t>
             </a:r>
           </a:p>
         </p:txBody>
@@ -5646,7 +5358,7 @@
                 </a:solidFill>
                 <a:latin typeface="Athelas"/>
               </a:rPr>
-              <a:t>Two layers, kept deliberately apart</a:t>
+              <a:t>Built to be universal</a:t>
             </a:r>
           </a:p>
         </p:txBody>
@@ -5659,8 +5371,8 @@
         </p:nvSpPr>
         <p:spPr>
           <a:xfrm>
-            <a:off x="914400" y="2331720"/>
-            <a:ext cx="4754880" cy="548640"/>
+            <a:off x="914400" y="2057400"/>
+            <a:ext cx="10362895" cy="1371600"/>
           </a:xfrm>
           <a:prstGeom prst="rect">
             <a:avLst/>
@@ -5673,149 +5385,38 @@
           </a:bodyPr>
           <a:lstStyle/>
           <a:p>
-            <a:pPr algn="l"/>
-            <a:r>
-              <a:rPr sz="2690" b="0" i="0">
+            <a:pPr algn="l">
+              <a:lnSpc>
+                <a:spcPct val="115000"/>
+              </a:lnSpc>
+            </a:pPr>
+            <a:r>
+              <a:rPr sz="2270" b="0" i="0">
                 <a:solidFill>
                   <a:srgbClr val="111A20"/>
                 </a:solidFill>
                 <a:latin typeface="Athelas"/>
               </a:rPr>
-              <a:t>Science layer</a:t>
-            </a:r>
-          </a:p>
-        </p:txBody>
-      </p:sp>
-      <p:sp>
-        <p:nvSpPr>
-          <p:cNvPr id="4" name="TextBox 3"/>
-          <p:cNvSpPr txBox="1"/>
-          <p:nvPr/>
-        </p:nvSpPr>
-        <p:spPr>
-          <a:xfrm>
-            <a:off x="914400" y="2926080"/>
-            <a:ext cx="4754880" cy="274320"/>
-          </a:xfrm>
-          <a:prstGeom prst="rect">
-            <a:avLst/>
-          </a:prstGeom>
-          <a:noFill/>
-        </p:spPr>
-        <p:txBody>
-          <a:bodyPr wrap="square" lIns="0" rIns="0" tIns="0" bIns="0" anchor="t">
-            <a:noAutofit/>
-          </a:bodyPr>
-          <a:lstStyle/>
-          <a:p>
-            <a:pPr algn="l"/>
-            <a:r>
-              <a:rPr sz="1010" b="1" i="0" spc="140">
-                <a:solidFill>
-                  <a:srgbClr val="5F6F78"/>
-                </a:solidFill>
-                <a:latin typeface="Frutiger"/>
-              </a:rPr>
-              <a:t>OBJECTIVE</a:t>
-            </a:r>
-          </a:p>
-        </p:txBody>
-      </p:sp>
-      <p:sp>
-        <p:nvSpPr>
-          <p:cNvPr id="5" name="TextBox 4"/>
-          <p:cNvSpPr txBox="1"/>
-          <p:nvPr/>
-        </p:nvSpPr>
-        <p:spPr>
-          <a:xfrm>
-            <a:off x="914400" y="3474720"/>
-            <a:ext cx="4754880" cy="2560320"/>
-          </a:xfrm>
-          <a:prstGeom prst="rect">
-            <a:avLst/>
-          </a:prstGeom>
-          <a:noFill/>
-        </p:spPr>
-        <p:txBody>
-          <a:bodyPr wrap="square" lIns="0" rIns="0" tIns="0" bIns="0" anchor="t">
-            <a:noAutofit/>
-          </a:bodyPr>
-          <a:lstStyle/>
-          <a:p>
-            <a:pPr algn="l">
-              <a:lnSpc>
-                <a:spcPct val="112000"/>
-              </a:lnSpc>
-              <a:spcAft>
-                <a:spcPts val="1200"/>
-              </a:spcAft>
-            </a:pPr>
-            <a:r>
-              <a:rPr sz="1390" b="0" i="0">
-                <a:solidFill>
-                  <a:srgbClr val="111A20"/>
-                </a:solidFill>
-                <a:latin typeface="Frutiger"/>
-              </a:rPr>
-              <a:t>Hong Kong rainfall, 1884–2025: annual peaks, the gaps between them, return periods.</a:t>
-            </a:r>
-          </a:p>
-          <a:p>
-            <a:pPr algn="l">
-              <a:lnSpc>
-                <a:spcPct val="112000"/>
-              </a:lnSpc>
-              <a:spcAft>
-                <a:spcPts val="1200"/>
-              </a:spcAft>
-            </a:pPr>
-            <a:r>
-              <a:rPr sz="1390" b="0" i="0">
-                <a:solidFill>
-                  <a:srgbClr val="111A20"/>
-                </a:solidFill>
-                <a:latin typeface="Frutiger"/>
-              </a:rPr>
-              <a:t>Rhine and alpine rivers, 8 stations: flow duration, recession, the seasonal cycle.</a:t>
-            </a:r>
-          </a:p>
-          <a:p>
-            <a:pPr algn="l">
-              <a:lnSpc>
-                <a:spcPct val="112000"/>
-              </a:lnSpc>
-              <a:spcAft>
-                <a:spcPts val="1200"/>
-              </a:spcAft>
-            </a:pPr>
-            <a:r>
-              <a:rPr sz="1390" b="0" i="0">
-                <a:solidFill>
-                  <a:srgbClr val="111A20"/>
-                </a:solidFill>
-                <a:latin typeface="Frutiger"/>
-              </a:rPr>
-              <a:t>Measures what happened. The measurements are never adjusted for artistic reasons.</a:t>
+              <a:t>Each record fits its own model on its own history. Another rainfall or river record can go through the same pipeline.</a:t>
             </a:r>
           </a:p>
         </p:txBody>
       </p:sp>
       <p:cxnSp>
         <p:nvCxnSpPr>
-          <p:cNvPr id="6" name="Connector 5"/>
+          <p:cNvPr id="4" name="Connector 3"/>
           <p:cNvCxnSpPr/>
           <p:nvPr/>
         </p:nvCxnSpPr>
         <p:spPr>
           <a:xfrm>
-            <a:off x="6096304" y="2377440"/>
-            <a:ext cx="0" cy="3566160"/>
+            <a:off x="914400" y="3703320"/>
+            <a:ext cx="10362895" cy="0"/>
           </a:xfrm>
           <a:prstGeom prst="line">
             <a:avLst/>
           </a:prstGeom>
-          <a:ln w="12700">
+          <a:ln w="15875">
             <a:solidFill>
               <a:srgbClr val="D3DDE2"/>
             </a:solidFill>
@@ -5838,14 +5439,14 @@
       </p:cxnSp>
       <p:sp>
         <p:nvSpPr>
-          <p:cNvPr id="7" name="TextBox 6"/>
+          <p:cNvPr id="5" name="TextBox 4"/>
           <p:cNvSpPr txBox="1"/>
           <p:nvPr/>
         </p:nvSpPr>
         <p:spPr>
           <a:xfrm>
-            <a:off x="6522415" y="2331720"/>
-            <a:ext cx="4754880" cy="548640"/>
+            <a:off x="914400" y="3886200"/>
+            <a:ext cx="3840480" cy="457200"/>
           </a:xfrm>
           <a:prstGeom prst="rect">
             <a:avLst/>
@@ -5860,17 +5461,87 @@
           <a:p>
             <a:pPr algn="l"/>
             <a:r>
-              <a:rPr sz="2690" b="0" i="0">
+              <a:rPr sz="1760" b="0" i="0">
                 <a:solidFill>
                   <a:srgbClr val="111A20"/>
                 </a:solidFill>
                 <a:latin typeface="Athelas"/>
               </a:rPr>
-              <a:t>Curatorial layer</a:t>
-            </a:r>
-          </a:p>
-        </p:txBody>
-      </p:sp>
+              <a:t>Hong Kong rainfall</a:t>
+            </a:r>
+          </a:p>
+        </p:txBody>
+      </p:sp>
+      <p:sp>
+        <p:nvSpPr>
+          <p:cNvPr id="6" name="TextBox 5"/>
+          <p:cNvSpPr txBox="1"/>
+          <p:nvPr/>
+        </p:nvSpPr>
+        <p:spPr>
+          <a:xfrm>
+            <a:off x="4937760" y="3950208"/>
+            <a:ext cx="6339535" cy="457200"/>
+          </a:xfrm>
+          <a:prstGeom prst="rect">
+            <a:avLst/>
+          </a:prstGeom>
+          <a:noFill/>
+        </p:spPr>
+        <p:txBody>
+          <a:bodyPr wrap="square" lIns="0" rIns="0" tIns="0" bIns="0" anchor="t">
+            <a:noAutofit/>
+          </a:bodyPr>
+          <a:lstStyle/>
+          <a:p>
+            <a:pPr algn="l"/>
+            <a:r>
+              <a:rPr sz="1180" b="0" i="0">
+                <a:solidFill>
+                  <a:srgbClr val="5F6F78"/>
+                </a:solidFill>
+                <a:latin typeface="Frutiger"/>
+              </a:rPr>
+              <a:t>Public record, Hong Kong Observatory. Daily, 1884–2025.</a:t>
+            </a:r>
+          </a:p>
+        </p:txBody>
+      </p:sp>
+      <p:cxnSp>
+        <p:nvCxnSpPr>
+          <p:cNvPr id="7" name="Connector 6"/>
+          <p:cNvCxnSpPr/>
+          <p:nvPr/>
+        </p:nvCxnSpPr>
+        <p:spPr>
+          <a:xfrm>
+            <a:off x="914400" y="4434840"/>
+            <a:ext cx="10362895" cy="0"/>
+          </a:xfrm>
+          <a:prstGeom prst="line">
+            <a:avLst/>
+          </a:prstGeom>
+          <a:ln w="15875">
+            <a:solidFill>
+              <a:srgbClr val="D3DDE2"/>
+            </a:solidFill>
+          </a:ln>
+        </p:spPr>
+        <p:style>
+          <a:lnRef idx="2">
+            <a:schemeClr val="accent1"/>
+          </a:lnRef>
+          <a:fillRef idx="0">
+            <a:schemeClr val="accent1"/>
+          </a:fillRef>
+          <a:effectRef idx="1">
+            <a:schemeClr val="accent1"/>
+          </a:effectRef>
+          <a:fontRef idx="minor">
+            <a:schemeClr val="tx1"/>
+          </a:fontRef>
+        </p:style>
+      </p:cxnSp>
       <p:sp>
         <p:nvSpPr>
           <p:cNvPr id="8" name="TextBox 7"/>
@@ -5879,8 +5550,8 @@
         </p:nvSpPr>
         <p:spPr>
           <a:xfrm>
-            <a:off x="6522415" y="2926080"/>
-            <a:ext cx="4754880" cy="274320"/>
+            <a:off x="914400" y="4617720"/>
+            <a:ext cx="3840480" cy="457200"/>
           </a:xfrm>
           <a:prstGeom prst="rect">
             <a:avLst/>
@@ -5895,13 +5566,13 @@
           <a:p>
             <a:pPr algn="l"/>
             <a:r>
-              <a:rPr sz="1010" b="1" i="0" spc="140">
-                <a:solidFill>
-                  <a:srgbClr val="00526F"/>
-                </a:solidFill>
-                <a:latin typeface="Frutiger"/>
+              <a:rPr sz="1760" b="0" i="0">
+                <a:solidFill>
+                  <a:srgbClr val="111A20"/>
+                </a:solidFill>
+                <a:latin typeface="Athelas"/>
               </a:rPr>
-              <a:t>DESIGNED</a:t>
+              <a:t>Rhine and alpine rivers</a:t>
             </a:r>
           </a:p>
         </p:txBody>
@@ -5914,8 +5585,8 @@
         </p:nvSpPr>
         <p:spPr>
           <a:xfrm>
-            <a:off x="6522415" y="3474720"/>
-            <a:ext cx="4754880" cy="2560320"/>
+            <a:off x="4937760" y="4681727"/>
+            <a:ext cx="6339535" cy="457200"/>
           </a:xfrm>
           <a:prstGeom prst="rect">
             <a:avLst/>
@@ -5928,67 +5599,127 @@
           </a:bodyPr>
           <a:lstStyle/>
           <a:p>
-            <a:pPr algn="l">
-              <a:lnSpc>
-                <a:spcPct val="112000"/>
-              </a:lnSpc>
-              <a:spcAft>
-                <a:spcPts val="1200"/>
-              </a:spcAft>
-            </a:pPr>
-            <a:r>
-              <a:rPr sz="1390" b="0" i="0">
-                <a:solidFill>
-                  <a:srgbClr val="111A20"/>
+            <a:pPr algn="l"/>
+            <a:r>
+              <a:rPr sz="1180" b="0" i="0">
+                <a:solidFill>
+                  <a:srgbClr val="5F6F78"/>
                 </a:solidFill>
                 <a:latin typeface="Frutiger"/>
               </a:rPr>
-              <a:t>Decides what a drought or a flood should feel like: how alarming, how heavy.</a:t>
-            </a:r>
-          </a:p>
-          <a:p>
-            <a:pPr algn="l">
-              <a:lnSpc>
-                <a:spcPct val="112000"/>
-              </a:lnSpc>
-              <a:spcAft>
-                <a:spcPts val="1200"/>
-              </a:spcAft>
-            </a:pPr>
-            <a:r>
-              <a:rPr sz="1390" b="0" i="0">
-                <a:solidFill>
-                  <a:srgbClr val="111A20"/>
+              <a:t>Public records, GRDC and FOEN. Daily, 8 stations.</a:t>
+            </a:r>
+          </a:p>
+        </p:txBody>
+      </p:sp>
+      <p:cxnSp>
+        <p:nvCxnSpPr>
+          <p:cNvPr id="10" name="Connector 9"/>
+          <p:cNvCxnSpPr/>
+          <p:nvPr/>
+        </p:nvCxnSpPr>
+        <p:spPr>
+          <a:xfrm>
+            <a:off x="914400" y="5166359"/>
+            <a:ext cx="10362895" cy="0"/>
+          </a:xfrm>
+          <a:prstGeom prst="line">
+            <a:avLst/>
+          </a:prstGeom>
+          <a:ln w="15875">
+            <a:solidFill>
+              <a:srgbClr val="D3DDE2"/>
+            </a:solidFill>
+          </a:ln>
+        </p:spPr>
+        <p:style>
+          <a:lnRef idx="2">
+            <a:schemeClr val="accent1"/>
+          </a:lnRef>
+          <a:fillRef idx="0">
+            <a:schemeClr val="accent1"/>
+          </a:fillRef>
+          <a:effectRef idx="1">
+            <a:schemeClr val="accent1"/>
+          </a:effectRef>
+          <a:fontRef idx="minor">
+            <a:schemeClr val="tx1"/>
+          </a:fontRef>
+        </p:style>
+      </p:cxnSp>
+      <p:sp>
+        <p:nvSpPr>
+          <p:cNvPr id="11" name="TextBox 10"/>
+          <p:cNvSpPr txBox="1"/>
+          <p:nvPr/>
+        </p:nvSpPr>
+        <p:spPr>
+          <a:xfrm>
+            <a:off x="914400" y="5349240"/>
+            <a:ext cx="3840480" cy="457200"/>
+          </a:xfrm>
+          <a:prstGeom prst="rect">
+            <a:avLst/>
+          </a:prstGeom>
+          <a:noFill/>
+        </p:spPr>
+        <p:txBody>
+          <a:bodyPr wrap="square" lIns="0" rIns="0" tIns="0" bIns="0" anchor="t">
+            <a:noAutofit/>
+          </a:bodyPr>
+          <a:lstStyle/>
+          <a:p>
+            <a:pPr algn="l"/>
+            <a:r>
+              <a:rPr sz="1760" b="0" i="0">
+                <a:solidFill>
+                  <a:srgbClr val="5F6F78"/>
+                </a:solidFill>
+                <a:latin typeface="Athelas"/>
+              </a:rPr>
+              <a:t>The next record</a:t>
+            </a:r>
+          </a:p>
+        </p:txBody>
+      </p:sp>
+      <p:sp>
+        <p:nvSpPr>
+          <p:cNvPr id="12" name="TextBox 11"/>
+          <p:cNvSpPr txBox="1"/>
+          <p:nvPr/>
+        </p:nvSpPr>
+        <p:spPr>
+          <a:xfrm>
+            <a:off x="4937760" y="5413248"/>
+            <a:ext cx="6339535" cy="457200"/>
+          </a:xfrm>
+          <a:prstGeom prst="rect">
+            <a:avLst/>
+          </a:prstGeom>
+          <a:noFill/>
+        </p:spPr>
+        <p:txBody>
+          <a:bodyPr wrap="square" lIns="0" rIns="0" tIns="0" bIns="0" anchor="t">
+            <a:noAutofit/>
+          </a:bodyPr>
+          <a:lstStyle/>
+          <a:p>
+            <a:pPr algn="l"/>
+            <a:r>
+              <a:rPr sz="1180" b="0" i="0">
+                <a:solidFill>
+                  <a:srgbClr val="5F6F78"/>
                 </a:solidFill>
                 <a:latin typeface="Frutiger"/>
               </a:rPr>
-              <a:t>Kept separate from the measurements, so the feeling can be redesigned without changing any of the science.</a:t>
-            </a:r>
-          </a:p>
-          <a:p>
-            <a:pPr algn="l">
-              <a:lnSpc>
-                <a:spcPct val="112000"/>
-              </a:lnSpc>
-              <a:spcAft>
-                <a:spcPts val="1200"/>
-              </a:spcAft>
-            </a:pPr>
-            <a:r>
-              <a:rPr sz="1390" b="0" i="0">
-                <a:solidFill>
-                  <a:srgbClr val="111A20"/>
-                </a:solidFill>
-                <a:latin typeface="Frutiger"/>
-              </a:rPr>
-              <a:t>Its output: valence and arousal.</a:t>
+              <a:t>Not yet run. Tested on two records so far.</a:t>
             </a:r>
           </a:p>
         </p:txBody>
       </p:sp>
       <p:pic>
         <p:nvPicPr>
-          <p:cNvPr id="10" name="Picture 9" descr="logo.png"/>
+          <p:cNvPr id="13" name="Picture 12" descr="logo.png"/>
           <p:cNvPicPr>
             <a:picLocks noChangeAspect="1"/>
           </p:cNvPicPr>
@@ -6012,7 +5743,7 @@
       </p:pic>
       <p:sp>
         <p:nvSpPr>
-          <p:cNvPr id="11" name="TextBox 10"/>
+          <p:cNvPr id="14" name="TextBox 13"/>
           <p:cNvSpPr txBox="1"/>
           <p:nvPr/>
         </p:nvSpPr>
@@ -6105,7 +5836,7 @@
                 </a:solidFill>
                 <a:latin typeface="Athelas"/>
               </a:rPr>
-              <a:t>Machine learning finds unusual years</a:t>
+              <a:t>Two layers, kept deliberately apart</a:t>
             </a:r>
           </a:p>
         </p:txBody>
@@ -6118,8 +5849,8 @@
         </p:nvSpPr>
         <p:spPr>
           <a:xfrm>
-            <a:off x="914400" y="1463040"/>
-            <a:ext cx="10362895" cy="365760"/>
+            <a:off x="914400" y="2331720"/>
+            <a:ext cx="4754880" cy="548640"/>
           </a:xfrm>
           <a:prstGeom prst="rect">
             <a:avLst/>
@@ -6134,20 +5865,320 @@
           <a:p>
             <a:pPr algn="l"/>
             <a:r>
-              <a:rPr sz="1340" b="0" i="0">
+              <a:rPr sz="2690" b="0" i="0">
+                <a:solidFill>
+                  <a:srgbClr val="111A20"/>
+                </a:solidFill>
+                <a:latin typeface="Athelas"/>
+              </a:rPr>
+              <a:t>Diagnostic layer</a:t>
+            </a:r>
+          </a:p>
+        </p:txBody>
+      </p:sp>
+      <p:sp>
+        <p:nvSpPr>
+          <p:cNvPr id="4" name="TextBox 3"/>
+          <p:cNvSpPr txBox="1"/>
+          <p:nvPr/>
+        </p:nvSpPr>
+        <p:spPr>
+          <a:xfrm>
+            <a:off x="914400" y="2926080"/>
+            <a:ext cx="4754880" cy="274320"/>
+          </a:xfrm>
+          <a:prstGeom prst="rect">
+            <a:avLst/>
+          </a:prstGeom>
+          <a:noFill/>
+        </p:spPr>
+        <p:txBody>
+          <a:bodyPr wrap="square" lIns="0" rIns="0" tIns="0" bIns="0" anchor="t">
+            <a:noAutofit/>
+          </a:bodyPr>
+          <a:lstStyle/>
+          <a:p>
+            <a:pPr algn="l"/>
+            <a:r>
+              <a:rPr sz="1010" b="1" i="0" spc="140">
                 <a:solidFill>
                   <a:srgbClr val="5F6F78"/>
                 </a:solidFill>
                 <a:latin typeface="Frutiger"/>
               </a:rPr>
-              <a:t>Its one job so far, unsupervised: learn what a typical year looks like, then score how badly each year fits.</a:t>
+              <a:t>PLAIN SCIENCE</a:t>
+            </a:r>
+          </a:p>
+        </p:txBody>
+      </p:sp>
+      <p:sp>
+        <p:nvSpPr>
+          <p:cNvPr id="5" name="TextBox 4"/>
+          <p:cNvSpPr txBox="1"/>
+          <p:nvPr/>
+        </p:nvSpPr>
+        <p:spPr>
+          <a:xfrm>
+            <a:off x="914400" y="3474720"/>
+            <a:ext cx="4754880" cy="2560320"/>
+          </a:xfrm>
+          <a:prstGeom prst="rect">
+            <a:avLst/>
+          </a:prstGeom>
+          <a:noFill/>
+        </p:spPr>
+        <p:txBody>
+          <a:bodyPr wrap="square" lIns="0" rIns="0" tIns="0" bIns="0" anchor="t">
+            <a:noAutofit/>
+          </a:bodyPr>
+          <a:lstStyle/>
+          <a:p>
+            <a:pPr algn="l">
+              <a:lnSpc>
+                <a:spcPct val="112000"/>
+              </a:lnSpc>
+              <a:spcAft>
+                <a:spcPts val="1200"/>
+              </a:spcAft>
+            </a:pPr>
+            <a:r>
+              <a:rPr sz="1390" b="0" i="0">
+                <a:solidFill>
+                  <a:srgbClr val="111A20"/>
+                </a:solidFill>
+                <a:latin typeface="Frutiger"/>
+              </a:rPr>
+              <a:t>Hong Kong rainfall, 1884–2025: annual peaks, the gaps between them, return periods.</a:t>
+            </a:r>
+          </a:p>
+          <a:p>
+            <a:pPr algn="l">
+              <a:lnSpc>
+                <a:spcPct val="112000"/>
+              </a:lnSpc>
+              <a:spcAft>
+                <a:spcPts val="1200"/>
+              </a:spcAft>
+            </a:pPr>
+            <a:r>
+              <a:rPr sz="1390" b="0" i="0">
+                <a:solidFill>
+                  <a:srgbClr val="111A20"/>
+                </a:solidFill>
+                <a:latin typeface="Frutiger"/>
+              </a:rPr>
+              <a:t>Rhine and alpine rivers, 8 stations: flow duration, recession, the seasonal cycle.</a:t>
+            </a:r>
+          </a:p>
+          <a:p>
+            <a:pPr algn="l">
+              <a:lnSpc>
+                <a:spcPct val="112000"/>
+              </a:lnSpc>
+              <a:spcAft>
+                <a:spcPts val="1200"/>
+              </a:spcAft>
+            </a:pPr>
+            <a:r>
+              <a:rPr sz="1390" b="0" i="0">
+                <a:solidFill>
+                  <a:srgbClr val="111A20"/>
+                </a:solidFill>
+                <a:latin typeface="Frutiger"/>
+              </a:rPr>
+              <a:t>Measures what happened, and is never adjusted for artistic reasons.</a:t>
+            </a:r>
+          </a:p>
+        </p:txBody>
+      </p:sp>
+      <p:cxnSp>
+        <p:nvCxnSpPr>
+          <p:cNvPr id="6" name="Connector 5"/>
+          <p:cNvCxnSpPr/>
+          <p:nvPr/>
+        </p:nvCxnSpPr>
+        <p:spPr>
+          <a:xfrm>
+            <a:off x="6096304" y="2377440"/>
+            <a:ext cx="0" cy="3566160"/>
+          </a:xfrm>
+          <a:prstGeom prst="line">
+            <a:avLst/>
+          </a:prstGeom>
+          <a:ln w="12700">
+            <a:solidFill>
+              <a:srgbClr val="D3DDE2"/>
+            </a:solidFill>
+          </a:ln>
+        </p:spPr>
+        <p:style>
+          <a:lnRef idx="2">
+            <a:schemeClr val="accent1"/>
+          </a:lnRef>
+          <a:fillRef idx="0">
+            <a:schemeClr val="accent1"/>
+          </a:fillRef>
+          <a:effectRef idx="1">
+            <a:schemeClr val="accent1"/>
+          </a:effectRef>
+          <a:fontRef idx="minor">
+            <a:schemeClr val="tx1"/>
+          </a:fontRef>
+        </p:style>
+      </p:cxnSp>
+      <p:sp>
+        <p:nvSpPr>
+          <p:cNvPr id="7" name="TextBox 6"/>
+          <p:cNvSpPr txBox="1"/>
+          <p:nvPr/>
+        </p:nvSpPr>
+        <p:spPr>
+          <a:xfrm>
+            <a:off x="6522415" y="2331720"/>
+            <a:ext cx="4754880" cy="548640"/>
+          </a:xfrm>
+          <a:prstGeom prst="rect">
+            <a:avLst/>
+          </a:prstGeom>
+          <a:noFill/>
+        </p:spPr>
+        <p:txBody>
+          <a:bodyPr wrap="square" lIns="0" rIns="0" tIns="0" bIns="0" anchor="t">
+            <a:noAutofit/>
+          </a:bodyPr>
+          <a:lstStyle/>
+          <a:p>
+            <a:pPr algn="l"/>
+            <a:r>
+              <a:rPr sz="2690" b="0" i="0">
+                <a:solidFill>
+                  <a:srgbClr val="111A20"/>
+                </a:solidFill>
+                <a:latin typeface="Athelas"/>
+              </a:rPr>
+              <a:t>Curatorial layer</a:t>
+            </a:r>
+          </a:p>
+        </p:txBody>
+      </p:sp>
+      <p:sp>
+        <p:nvSpPr>
+          <p:cNvPr id="8" name="TextBox 7"/>
+          <p:cNvSpPr txBox="1"/>
+          <p:nvPr/>
+        </p:nvSpPr>
+        <p:spPr>
+          <a:xfrm>
+            <a:off x="6522415" y="2926080"/>
+            <a:ext cx="4754880" cy="274320"/>
+          </a:xfrm>
+          <a:prstGeom prst="rect">
+            <a:avLst/>
+          </a:prstGeom>
+          <a:noFill/>
+        </p:spPr>
+        <p:txBody>
+          <a:bodyPr wrap="square" lIns="0" rIns="0" tIns="0" bIns="0" anchor="t">
+            <a:noAutofit/>
+          </a:bodyPr>
+          <a:lstStyle/>
+          <a:p>
+            <a:pPr algn="l"/>
+            <a:r>
+              <a:rPr sz="1010" b="1" i="0" spc="140">
+                <a:solidFill>
+                  <a:srgbClr val="00526F"/>
+                </a:solidFill>
+                <a:latin typeface="Frutiger"/>
+              </a:rPr>
+              <a:t>DESIGNED</a:t>
+            </a:r>
+          </a:p>
+        </p:txBody>
+      </p:sp>
+      <p:sp>
+        <p:nvSpPr>
+          <p:cNvPr id="9" name="TextBox 8"/>
+          <p:cNvSpPr txBox="1"/>
+          <p:nvPr/>
+        </p:nvSpPr>
+        <p:spPr>
+          <a:xfrm>
+            <a:off x="6522415" y="3474720"/>
+            <a:ext cx="4754880" cy="2560320"/>
+          </a:xfrm>
+          <a:prstGeom prst="rect">
+            <a:avLst/>
+          </a:prstGeom>
+          <a:noFill/>
+        </p:spPr>
+        <p:txBody>
+          <a:bodyPr wrap="square" lIns="0" rIns="0" tIns="0" bIns="0" anchor="t">
+            <a:noAutofit/>
+          </a:bodyPr>
+          <a:lstStyle/>
+          <a:p>
+            <a:pPr algn="l">
+              <a:lnSpc>
+                <a:spcPct val="112000"/>
+              </a:lnSpc>
+              <a:spcAft>
+                <a:spcPts val="1200"/>
+              </a:spcAft>
+            </a:pPr>
+            <a:r>
+              <a:rPr sz="1390" b="0" i="0">
+                <a:solidFill>
+                  <a:srgbClr val="111A20"/>
+                </a:solidFill>
+                <a:latin typeface="Frutiger"/>
+              </a:rPr>
+              <a:t>Decides how the results should feel: how alarming, how heavy.</a:t>
+            </a:r>
+          </a:p>
+          <a:p>
+            <a:pPr algn="l">
+              <a:lnSpc>
+                <a:spcPct val="112000"/>
+              </a:lnSpc>
+              <a:spcAft>
+                <a:spcPts val="1200"/>
+              </a:spcAft>
+            </a:pPr>
+            <a:r>
+              <a:rPr sz="1390" b="0" i="0">
+                <a:solidFill>
+                  <a:srgbClr val="111A20"/>
+                </a:solidFill>
+                <a:latin typeface="Frutiger"/>
+              </a:rPr>
+              <a:t>Currently kept separate from the measurements, so the feeling could be redesigned without changing any of the science.</a:t>
+            </a:r>
+          </a:p>
+          <a:p>
+            <a:pPr algn="l">
+              <a:lnSpc>
+                <a:spcPct val="112000"/>
+              </a:lnSpc>
+              <a:spcAft>
+                <a:spcPts val="1200"/>
+              </a:spcAft>
+            </a:pPr>
+            <a:r>
+              <a:rPr sz="1390" b="0" i="0">
+                <a:solidFill>
+                  <a:srgbClr val="111A20"/>
+                </a:solidFill>
+                <a:latin typeface="Frutiger"/>
+              </a:rPr>
+              <a:t>Its output: valence and arousal.</a:t>
             </a:r>
           </a:p>
         </p:txBody>
       </p:sp>
       <p:pic>
         <p:nvPicPr>
-          <p:cNvPr id="4" name="Picture 3" descr="anomaly_floods2.png"/>
+          <p:cNvPr id="10" name="Picture 9" descr="logo.png"/>
           <p:cNvPicPr>
             <a:picLocks noChangeAspect="1"/>
           </p:cNvPicPr>
@@ -6161,113 +6192,6 @@
         </p:blipFill>
         <p:spPr>
           <a:xfrm>
-            <a:off x="914400" y="2148840"/>
-            <a:ext cx="10362895" cy="3019046"/>
-          </a:xfrm>
-          <a:prstGeom prst="rect">
-            <a:avLst/>
-          </a:prstGeom>
-        </p:spPr>
-      </p:pic>
-      <p:sp>
-        <p:nvSpPr>
-          <p:cNvPr id="5" name="TextBox 4"/>
-          <p:cNvSpPr txBox="1"/>
-          <p:nvPr/>
-        </p:nvSpPr>
-        <p:spPr>
-          <a:xfrm>
-            <a:off x="914400" y="5230368"/>
-            <a:ext cx="10362895" cy="365760"/>
-          </a:xfrm>
-          <a:prstGeom prst="rect">
-            <a:avLst/>
-          </a:prstGeom>
-          <a:noFill/>
-        </p:spPr>
-        <p:txBody>
-          <a:bodyPr wrap="square" lIns="0" rIns="0" tIns="0" bIns="0" anchor="t">
-            <a:noAutofit/>
-          </a:bodyPr>
-          <a:lstStyle/>
-          <a:p>
-            <a:pPr algn="l"/>
-            <a:r>
-              <a:rPr sz="1260" b="1" i="0">
-                <a:solidFill>
-                  <a:srgbClr val="111A20"/>
-                </a:solidFill>
-                <a:latin typeface="Frutiger"/>
-              </a:rPr>
-              <a:t>The highlighted bar is each station's highest-scoring year. </a:t>
-            </a:r>
-            <a:r>
-              <a:rPr sz="1260" b="0" i="0">
-                <a:solidFill>
-                  <a:srgbClr val="111A20"/>
-                </a:solidFill>
-                <a:latin typeface="Frutiger"/>
-              </a:rPr>
-              <a:t>The model was never told these events existed.</a:t>
-            </a:r>
-          </a:p>
-        </p:txBody>
-      </p:sp>
-      <p:sp>
-        <p:nvSpPr>
-          <p:cNvPr id="6" name="TextBox 5"/>
-          <p:cNvSpPr txBox="1"/>
-          <p:nvPr/>
-        </p:nvSpPr>
-        <p:spPr>
-          <a:xfrm>
-            <a:off x="914400" y="5623560"/>
-            <a:ext cx="10362895" cy="457200"/>
-          </a:xfrm>
-          <a:prstGeom prst="rect">
-            <a:avLst/>
-          </a:prstGeom>
-          <a:noFill/>
-        </p:spPr>
-        <p:txBody>
-          <a:bodyPr wrap="square" lIns="0" rIns="0" tIns="0" bIns="0" anchor="t">
-            <a:noAutofit/>
-          </a:bodyPr>
-          <a:lstStyle/>
-          <a:p>
-            <a:pPr algn="l">
-              <a:lnSpc>
-                <a:spcPct val="108000"/>
-              </a:lnSpc>
-            </a:pPr>
-            <a:r>
-              <a:rPr sz="1000" b="0" i="0">
-                <a:solidFill>
-                  <a:srgbClr val="5F6F78"/>
-                </a:solidFill>
-                <a:latin typeface="Frutiger"/>
-              </a:rPr>
-              <a:t>Method: PCA reconstruction error, fit separately per station on its own years. Events: Aug 2005 Alpine floods (22–23 Aug), May 1999 Swiss floods (Thun, 15 May), Christmas 1993 Rhine flood (Köln, 24 Dec).</a:t>
-            </a:r>
-          </a:p>
-        </p:txBody>
-      </p:sp>
-      <p:pic>
-        <p:nvPicPr>
-          <p:cNvPr id="7" name="Picture 6" descr="logo.png"/>
-          <p:cNvPicPr>
-            <a:picLocks noChangeAspect="1"/>
-          </p:cNvPicPr>
-          <p:nvPr/>
-        </p:nvPicPr>
-        <p:blipFill>
-          <a:blip r:embed="rId4"/>
-          <a:stretch>
-            <a:fillRect/>
-          </a:stretch>
-        </p:blipFill>
-        <p:spPr>
-          <a:xfrm>
             <a:off x="914400" y="6236208"/>
             <a:ext cx="2120348" cy="292608"/>
           </a:xfrm>
@@ -6278,7 +6202,7 @@
       </p:pic>
       <p:sp>
         <p:nvSpPr>
-          <p:cNvPr id="8" name="TextBox 7"/>
+          <p:cNvPr id="11" name="TextBox 10"/>
           <p:cNvSpPr txBox="1"/>
           <p:nvPr/>
         </p:nvSpPr>
@@ -6371,7 +6295,7 @@
                 </a:solidFill>
                 <a:latin typeface="Athelas"/>
               </a:rPr>
-              <a:t>Built to travel</a:t>
+              <a:t>Machine learning finds unusual years</a:t>
             </a:r>
           </a:p>
         </p:txBody>
@@ -6406,525 +6330,14 @@
                 </a:solidFill>
                 <a:latin typeface="Frutiger"/>
               </a:rPr>
-              <a:t>Each record fits its own model on its own history. Another rainfall or river record can go through the same pipeline.</a:t>
-            </a:r>
-          </a:p>
-        </p:txBody>
-      </p:sp>
-      <p:cxnSp>
-        <p:nvCxnSpPr>
-          <p:cNvPr id="4" name="Connector 3"/>
-          <p:cNvCxnSpPr/>
-          <p:nvPr/>
-        </p:nvCxnSpPr>
-        <p:spPr>
-          <a:xfrm>
-            <a:off x="914400" y="2926080"/>
-            <a:ext cx="3200400" cy="0"/>
-          </a:xfrm>
-          <a:prstGeom prst="line">
-            <a:avLst/>
-          </a:prstGeom>
-          <a:ln w="38100">
-            <a:solidFill>
-              <a:srgbClr val="00526F"/>
-            </a:solidFill>
-          </a:ln>
-        </p:spPr>
-        <p:style>
-          <a:lnRef idx="2">
-            <a:schemeClr val="accent1"/>
-          </a:lnRef>
-          <a:fillRef idx="0">
-            <a:schemeClr val="accent1"/>
-          </a:fillRef>
-          <a:effectRef idx="1">
-            <a:schemeClr val="accent1"/>
-          </a:effectRef>
-          <a:fontRef idx="minor">
-            <a:schemeClr val="tx1"/>
-          </a:fontRef>
-        </p:style>
-      </p:cxnSp>
-      <p:sp>
-        <p:nvSpPr>
-          <p:cNvPr id="5" name="TextBox 4"/>
-          <p:cNvSpPr txBox="1"/>
-          <p:nvPr/>
-        </p:nvSpPr>
-        <p:spPr>
-          <a:xfrm>
-            <a:off x="914400" y="3200400"/>
-            <a:ext cx="3200400" cy="274320"/>
-          </a:xfrm>
-          <a:prstGeom prst="rect">
-            <a:avLst/>
-          </a:prstGeom>
-          <a:noFill/>
-        </p:spPr>
-        <p:txBody>
-          <a:bodyPr wrap="square" lIns="0" rIns="0" tIns="0" bIns="0" anchor="t">
-            <a:noAutofit/>
-          </a:bodyPr>
-          <a:lstStyle/>
-          <a:p>
-            <a:pPr algn="l"/>
-            <a:r>
-              <a:rPr sz="1010" b="1" i="0" spc="140">
-                <a:solidFill>
-                  <a:srgbClr val="00526F"/>
-                </a:solidFill>
-                <a:latin typeface="Frutiger"/>
-              </a:rPr>
-              <a:t>HONG KONG OBSERVATORY</a:t>
-            </a:r>
-          </a:p>
-        </p:txBody>
-      </p:sp>
-      <p:sp>
-        <p:nvSpPr>
-          <p:cNvPr id="6" name="TextBox 5"/>
-          <p:cNvSpPr txBox="1"/>
-          <p:nvPr/>
-        </p:nvSpPr>
-        <p:spPr>
-          <a:xfrm>
-            <a:off x="914400" y="3657600"/>
-            <a:ext cx="3108960" cy="914400"/>
-          </a:xfrm>
-          <a:prstGeom prst="rect">
-            <a:avLst/>
-          </a:prstGeom>
-          <a:noFill/>
-        </p:spPr>
-        <p:txBody>
-          <a:bodyPr wrap="square" lIns="0" rIns="0" tIns="0" bIns="0" anchor="t">
-            <a:noAutofit/>
-          </a:bodyPr>
-          <a:lstStyle/>
-          <a:p>
-            <a:pPr algn="l">
-              <a:lnSpc>
-                <a:spcPct val="100000"/>
-              </a:lnSpc>
-            </a:pPr>
-            <a:r>
-              <a:rPr sz="2180" b="0" i="0">
-                <a:solidFill>
-                  <a:srgbClr val="111A20"/>
-                </a:solidFill>
-                <a:latin typeface="Athelas"/>
-              </a:rPr>
-              <a:t>Hong Kong rainfall</a:t>
-            </a:r>
-          </a:p>
-        </p:txBody>
-      </p:sp>
-      <p:sp>
-        <p:nvSpPr>
-          <p:cNvPr id="7" name="TextBox 6"/>
-          <p:cNvSpPr txBox="1"/>
-          <p:nvPr/>
-        </p:nvSpPr>
-        <p:spPr>
-          <a:xfrm>
-            <a:off x="914400" y="4709160"/>
-            <a:ext cx="3108960" cy="1463040"/>
-          </a:xfrm>
-          <a:prstGeom prst="rect">
-            <a:avLst/>
-          </a:prstGeom>
-          <a:noFill/>
-        </p:spPr>
-        <p:txBody>
-          <a:bodyPr wrap="square" lIns="0" rIns="0" tIns="0" bIns="0" anchor="t">
-            <a:noAutofit/>
-          </a:bodyPr>
-          <a:lstStyle/>
-          <a:p>
-            <a:pPr algn="l">
-              <a:lnSpc>
-                <a:spcPct val="112000"/>
-              </a:lnSpc>
-              <a:spcAft>
-                <a:spcPts val="700"/>
-              </a:spcAft>
-            </a:pPr>
-            <a:r>
-              <a:rPr sz="1300" b="0" i="0">
-                <a:solidFill>
-                  <a:srgbClr val="111A20"/>
-                </a:solidFill>
-                <a:latin typeface="Frutiger"/>
-              </a:rPr>
-              <a:t>Daily, 1884–2025</a:t>
-            </a:r>
-          </a:p>
-          <a:p>
-            <a:pPr algn="l">
-              <a:lnSpc>
-                <a:spcPct val="112000"/>
-              </a:lnSpc>
-              <a:spcAft>
-                <a:spcPts val="700"/>
-              </a:spcAft>
-            </a:pPr>
-            <a:r>
-              <a:rPr sz="1300" b="0" i="0">
-                <a:solidFill>
-                  <a:srgbClr val="111A20"/>
-                </a:solidFill>
-                <a:latin typeface="Frutiger"/>
-              </a:rPr>
-              <a:t>One model, fit on 134 years</a:t>
-            </a:r>
-          </a:p>
-        </p:txBody>
-      </p:sp>
-      <p:cxnSp>
-        <p:nvCxnSpPr>
-          <p:cNvPr id="8" name="Connector 7"/>
-          <p:cNvCxnSpPr/>
-          <p:nvPr/>
-        </p:nvCxnSpPr>
-        <p:spPr>
-          <a:xfrm>
-            <a:off x="4494276" y="2926080"/>
-            <a:ext cx="3200399" cy="0"/>
-          </a:xfrm>
-          <a:prstGeom prst="line">
-            <a:avLst/>
-          </a:prstGeom>
-          <a:ln w="38100">
-            <a:solidFill>
-              <a:srgbClr val="00526F"/>
-            </a:solidFill>
-          </a:ln>
-        </p:spPr>
-        <p:style>
-          <a:lnRef idx="2">
-            <a:schemeClr val="accent1"/>
-          </a:lnRef>
-          <a:fillRef idx="0">
-            <a:schemeClr val="accent1"/>
-          </a:fillRef>
-          <a:effectRef idx="1">
-            <a:schemeClr val="accent1"/>
-          </a:effectRef>
-          <a:fontRef idx="minor">
-            <a:schemeClr val="tx1"/>
-          </a:fontRef>
-        </p:style>
-      </p:cxnSp>
-      <p:sp>
-        <p:nvSpPr>
-          <p:cNvPr id="9" name="TextBox 8"/>
-          <p:cNvSpPr txBox="1"/>
-          <p:nvPr/>
-        </p:nvSpPr>
-        <p:spPr>
-          <a:xfrm>
-            <a:off x="4494276" y="3200400"/>
-            <a:ext cx="3200400" cy="274320"/>
-          </a:xfrm>
-          <a:prstGeom prst="rect">
-            <a:avLst/>
-          </a:prstGeom>
-          <a:noFill/>
-        </p:spPr>
-        <p:txBody>
-          <a:bodyPr wrap="square" lIns="0" rIns="0" tIns="0" bIns="0" anchor="t">
-            <a:noAutofit/>
-          </a:bodyPr>
-          <a:lstStyle/>
-          <a:p>
-            <a:pPr algn="l"/>
-            <a:r>
-              <a:rPr sz="1010" b="1" i="0" spc="140">
-                <a:solidFill>
-                  <a:srgbClr val="00526F"/>
-                </a:solidFill>
-                <a:latin typeface="Frutiger"/>
-              </a:rPr>
-              <a:t>GRDC, FOEN</a:t>
-            </a:r>
-          </a:p>
-        </p:txBody>
-      </p:sp>
-      <p:sp>
-        <p:nvSpPr>
-          <p:cNvPr id="10" name="TextBox 9"/>
-          <p:cNvSpPr txBox="1"/>
-          <p:nvPr/>
-        </p:nvSpPr>
-        <p:spPr>
-          <a:xfrm>
-            <a:off x="4494276" y="3657600"/>
-            <a:ext cx="3108960" cy="914400"/>
-          </a:xfrm>
-          <a:prstGeom prst="rect">
-            <a:avLst/>
-          </a:prstGeom>
-          <a:noFill/>
-        </p:spPr>
-        <p:txBody>
-          <a:bodyPr wrap="square" lIns="0" rIns="0" tIns="0" bIns="0" anchor="t">
-            <a:noAutofit/>
-          </a:bodyPr>
-          <a:lstStyle/>
-          <a:p>
-            <a:pPr algn="l">
-              <a:lnSpc>
-                <a:spcPct val="100000"/>
-              </a:lnSpc>
-            </a:pPr>
-            <a:r>
-              <a:rPr sz="2180" b="0" i="0">
-                <a:solidFill>
-                  <a:srgbClr val="111A20"/>
-                </a:solidFill>
-                <a:latin typeface="Athelas"/>
-              </a:rPr>
-              <a:t>Rhine and alpine rivers</a:t>
-            </a:r>
-          </a:p>
-        </p:txBody>
-      </p:sp>
-      <p:sp>
-        <p:nvSpPr>
-          <p:cNvPr id="11" name="TextBox 10"/>
-          <p:cNvSpPr txBox="1"/>
-          <p:nvPr/>
-        </p:nvSpPr>
-        <p:spPr>
-          <a:xfrm>
-            <a:off x="4494276" y="4709160"/>
-            <a:ext cx="3108960" cy="1463040"/>
-          </a:xfrm>
-          <a:prstGeom prst="rect">
-            <a:avLst/>
-          </a:prstGeom>
-          <a:noFill/>
-        </p:spPr>
-        <p:txBody>
-          <a:bodyPr wrap="square" lIns="0" rIns="0" tIns="0" bIns="0" anchor="t">
-            <a:noAutofit/>
-          </a:bodyPr>
-          <a:lstStyle/>
-          <a:p>
-            <a:pPr algn="l">
-              <a:lnSpc>
-                <a:spcPct val="112000"/>
-              </a:lnSpc>
-              <a:spcAft>
-                <a:spcPts val="700"/>
-              </a:spcAft>
-            </a:pPr>
-            <a:r>
-              <a:rPr sz="1300" b="0" i="0">
-                <a:solidFill>
-                  <a:srgbClr val="111A20"/>
-                </a:solidFill>
-                <a:latin typeface="Frutiger"/>
-              </a:rPr>
-              <a:t>Daily, 8 stations</a:t>
-            </a:r>
-          </a:p>
-          <a:p>
-            <a:pPr algn="l">
-              <a:lnSpc>
-                <a:spcPct val="112000"/>
-              </a:lnSpc>
-              <a:spcAft>
-                <a:spcPts val="700"/>
-              </a:spcAft>
-            </a:pPr>
-            <a:r>
-              <a:rPr sz="1300" b="0" i="0">
-                <a:solidFill>
-                  <a:srgbClr val="111A20"/>
-                </a:solidFill>
-                <a:latin typeface="Frutiger"/>
-              </a:rPr>
-              <a:t>One model per station, 62–208 years</a:t>
-            </a:r>
-          </a:p>
-        </p:txBody>
-      </p:sp>
-      <p:cxnSp>
-        <p:nvCxnSpPr>
-          <p:cNvPr id="12" name="Connector 11"/>
-          <p:cNvCxnSpPr/>
-          <p:nvPr/>
-        </p:nvCxnSpPr>
-        <p:spPr>
-          <a:xfrm>
-            <a:off x="8074152" y="2926080"/>
-            <a:ext cx="3200400" cy="0"/>
-          </a:xfrm>
-          <a:prstGeom prst="line">
-            <a:avLst/>
-          </a:prstGeom>
-          <a:ln w="22225">
-            <a:solidFill>
-              <a:srgbClr val="5390A2"/>
-            </a:solidFill>
-            <a:prstDash val="dash"/>
-          </a:ln>
-        </p:spPr>
-        <p:style>
-          <a:lnRef idx="2">
-            <a:schemeClr val="accent1"/>
-          </a:lnRef>
-          <a:fillRef idx="0">
-            <a:schemeClr val="accent1"/>
-          </a:fillRef>
-          <a:effectRef idx="1">
-            <a:schemeClr val="accent1"/>
-          </a:effectRef>
-          <a:fontRef idx="minor">
-            <a:schemeClr val="tx1"/>
-          </a:fontRef>
-        </p:style>
-      </p:cxnSp>
-      <p:sp>
-        <p:nvSpPr>
-          <p:cNvPr id="13" name="TextBox 12"/>
-          <p:cNvSpPr txBox="1"/>
-          <p:nvPr/>
-        </p:nvSpPr>
-        <p:spPr>
-          <a:xfrm>
-            <a:off x="8074152" y="3200400"/>
-            <a:ext cx="3200400" cy="274320"/>
-          </a:xfrm>
-          <a:prstGeom prst="rect">
-            <a:avLst/>
-          </a:prstGeom>
-          <a:noFill/>
-        </p:spPr>
-        <p:txBody>
-          <a:bodyPr wrap="square" lIns="0" rIns="0" tIns="0" bIns="0" anchor="t">
-            <a:noAutofit/>
-          </a:bodyPr>
-          <a:lstStyle/>
-          <a:p>
-            <a:pPr algn="l"/>
-            <a:r>
-              <a:rPr sz="1010" b="1" i="0" spc="140">
-                <a:solidFill>
-                  <a:srgbClr val="5F6F78"/>
-                </a:solidFill>
-                <a:latin typeface="Frutiger"/>
-              </a:rPr>
-              <a:t>NOT YET RUN</a:t>
-            </a:r>
-          </a:p>
-        </p:txBody>
-      </p:sp>
-      <p:sp>
-        <p:nvSpPr>
-          <p:cNvPr id="14" name="TextBox 13"/>
-          <p:cNvSpPr txBox="1"/>
-          <p:nvPr/>
-        </p:nvSpPr>
-        <p:spPr>
-          <a:xfrm>
-            <a:off x="8074152" y="3657600"/>
-            <a:ext cx="3108960" cy="914400"/>
-          </a:xfrm>
-          <a:prstGeom prst="rect">
-            <a:avLst/>
-          </a:prstGeom>
-          <a:noFill/>
-        </p:spPr>
-        <p:txBody>
-          <a:bodyPr wrap="square" lIns="0" rIns="0" tIns="0" bIns="0" anchor="t">
-            <a:noAutofit/>
-          </a:bodyPr>
-          <a:lstStyle/>
-          <a:p>
-            <a:pPr algn="l">
-              <a:lnSpc>
-                <a:spcPct val="100000"/>
-              </a:lnSpc>
-            </a:pPr>
-            <a:r>
-              <a:rPr sz="2180" b="0" i="0">
-                <a:solidFill>
-                  <a:srgbClr val="5F6F78"/>
-                </a:solidFill>
-                <a:latin typeface="Athelas"/>
-              </a:rPr>
-              <a:t>The next record</a:t>
-            </a:r>
-          </a:p>
-        </p:txBody>
-      </p:sp>
-      <p:sp>
-        <p:nvSpPr>
-          <p:cNvPr id="15" name="TextBox 14"/>
-          <p:cNvSpPr txBox="1"/>
-          <p:nvPr/>
-        </p:nvSpPr>
-        <p:spPr>
-          <a:xfrm>
-            <a:off x="8074152" y="4709160"/>
-            <a:ext cx="3108960" cy="1463040"/>
-          </a:xfrm>
-          <a:prstGeom prst="rect">
-            <a:avLst/>
-          </a:prstGeom>
-          <a:noFill/>
-        </p:spPr>
-        <p:txBody>
-          <a:bodyPr wrap="square" lIns="0" rIns="0" tIns="0" bIns="0" anchor="t">
-            <a:noAutofit/>
-          </a:bodyPr>
-          <a:lstStyle/>
-          <a:p>
-            <a:pPr algn="l">
-              <a:lnSpc>
-                <a:spcPct val="112000"/>
-              </a:lnSpc>
-              <a:spcAft>
-                <a:spcPts val="700"/>
-              </a:spcAft>
-            </a:pPr>
-            <a:r>
-              <a:rPr sz="1300" b="0" i="0">
-                <a:solidFill>
-                  <a:srgbClr val="5F6F78"/>
-                </a:solidFill>
-                <a:latin typeface="Frutiger"/>
-              </a:rPr>
-              <a:t>Another long rainfall or river series.</a:t>
-            </a:r>
-          </a:p>
-          <a:p>
-            <a:pPr algn="l">
-              <a:lnSpc>
-                <a:spcPct val="112000"/>
-              </a:lnSpc>
-              <a:spcAft>
-                <a:spcPts val="700"/>
-              </a:spcAft>
-            </a:pPr>
-            <a:r>
-              <a:rPr sz="1300" b="0" i="0">
-                <a:solidFill>
-                  <a:srgbClr val="5F6F78"/>
-                </a:solidFill>
-                <a:latin typeface="Frutiger"/>
-              </a:rPr>
-              <a:t>Tested on two records so far.</a:t>
+              <a:t>Its one job so far, unsupervised: learn what a typical year looks like, then score how badly each year fits.</a:t>
             </a:r>
           </a:p>
         </p:txBody>
       </p:sp>
       <p:pic>
         <p:nvPicPr>
-          <p:cNvPr id="16" name="Picture 15" descr="logo.png"/>
+          <p:cNvPr id="4" name="Picture 3" descr="anomaly_floods2.png"/>
           <p:cNvPicPr>
             <a:picLocks noChangeAspect="1"/>
           </p:cNvPicPr>
@@ -6938,6 +6351,113 @@
         </p:blipFill>
         <p:spPr>
           <a:xfrm>
+            <a:off x="914400" y="2148840"/>
+            <a:ext cx="10362895" cy="3019046"/>
+          </a:xfrm>
+          <a:prstGeom prst="rect">
+            <a:avLst/>
+          </a:prstGeom>
+        </p:spPr>
+      </p:pic>
+      <p:sp>
+        <p:nvSpPr>
+          <p:cNvPr id="5" name="TextBox 4"/>
+          <p:cNvSpPr txBox="1"/>
+          <p:nvPr/>
+        </p:nvSpPr>
+        <p:spPr>
+          <a:xfrm>
+            <a:off x="914400" y="5230368"/>
+            <a:ext cx="10362895" cy="365760"/>
+          </a:xfrm>
+          <a:prstGeom prst="rect">
+            <a:avLst/>
+          </a:prstGeom>
+          <a:noFill/>
+        </p:spPr>
+        <p:txBody>
+          <a:bodyPr wrap="square" lIns="0" rIns="0" tIns="0" bIns="0" anchor="t">
+            <a:noAutofit/>
+          </a:bodyPr>
+          <a:lstStyle/>
+          <a:p>
+            <a:pPr algn="l"/>
+            <a:r>
+              <a:rPr sz="1260" b="1" i="0">
+                <a:solidFill>
+                  <a:srgbClr val="111A20"/>
+                </a:solidFill>
+                <a:latin typeface="Frutiger"/>
+              </a:rPr>
+              <a:t>The highlighted bar is each station's highest-scoring year. </a:t>
+            </a:r>
+            <a:r>
+              <a:rPr sz="1260" b="0" i="0">
+                <a:solidFill>
+                  <a:srgbClr val="111A20"/>
+                </a:solidFill>
+                <a:latin typeface="Frutiger"/>
+              </a:rPr>
+              <a:t>The model was never told these events existed.</a:t>
+            </a:r>
+          </a:p>
+        </p:txBody>
+      </p:sp>
+      <p:sp>
+        <p:nvSpPr>
+          <p:cNvPr id="6" name="TextBox 5"/>
+          <p:cNvSpPr txBox="1"/>
+          <p:nvPr/>
+        </p:nvSpPr>
+        <p:spPr>
+          <a:xfrm>
+            <a:off x="914400" y="5623560"/>
+            <a:ext cx="10362895" cy="457200"/>
+          </a:xfrm>
+          <a:prstGeom prst="rect">
+            <a:avLst/>
+          </a:prstGeom>
+          <a:noFill/>
+        </p:spPr>
+        <p:txBody>
+          <a:bodyPr wrap="square" lIns="0" rIns="0" tIns="0" bIns="0" anchor="t">
+            <a:noAutofit/>
+          </a:bodyPr>
+          <a:lstStyle/>
+          <a:p>
+            <a:pPr algn="l">
+              <a:lnSpc>
+                <a:spcPct val="108000"/>
+              </a:lnSpc>
+            </a:pPr>
+            <a:r>
+              <a:rPr sz="1000" b="0" i="0">
+                <a:solidFill>
+                  <a:srgbClr val="5F6F78"/>
+                </a:solidFill>
+                <a:latin typeface="Frutiger"/>
+              </a:rPr>
+              <a:t>Method: PCA reconstruction error, fit separately per station on its own years. Events: Aug 2005 Alpine floods (22–23 Aug), May 1999 Swiss floods (Thun, 15 May), Christmas 1993 Rhine flood (Köln, 24 Dec).</a:t>
+            </a:r>
+          </a:p>
+        </p:txBody>
+      </p:sp>
+      <p:pic>
+        <p:nvPicPr>
+          <p:cNvPr id="7" name="Picture 6" descr="logo.png"/>
+          <p:cNvPicPr>
+            <a:picLocks noChangeAspect="1"/>
+          </p:cNvPicPr>
+          <p:nvPr/>
+        </p:nvPicPr>
+        <p:blipFill>
+          <a:blip r:embed="rId4"/>
+          <a:stretch>
+            <a:fillRect/>
+          </a:stretch>
+        </p:blipFill>
+        <p:spPr>
+          <a:xfrm>
             <a:off x="914400" y="6236208"/>
             <a:ext cx="2120348" cy="292608"/>
           </a:xfrm>
@@ -6948,7 +6468,7 @@
       </p:pic>
       <p:sp>
         <p:nvSpPr>
-          <p:cNvPr id="17" name="TextBox 16"/>
+          <p:cNvPr id="8" name="TextBox 7"/>
           <p:cNvSpPr txBox="1"/>
           <p:nvPr/>
         </p:nvSpPr>
@@ -7054,8 +6574,8 @@
         </p:nvSpPr>
         <p:spPr>
           <a:xfrm>
-            <a:off x="914400" y="1463040"/>
-            <a:ext cx="10362895" cy="365760"/>
+            <a:off x="914400" y="2103120"/>
+            <a:ext cx="10362895" cy="1828800"/>
           </a:xfrm>
           <a:prstGeom prst="rect">
             <a:avLst/>
@@ -7068,15 +6588,19 @@
           </a:bodyPr>
           <a:lstStyle/>
           <a:p>
-            <a:pPr algn="l"/>
-            <a:r>
-              <a:rPr sz="1340" b="0" i="0">
-                <a:solidFill>
-                  <a:srgbClr val="5F6F78"/>
-                </a:solidFill>
-                <a:latin typeface="Frutiger"/>
+            <a:pPr algn="l">
+              <a:lnSpc>
+                <a:spcPct val="115000"/>
+              </a:lnSpc>
+            </a:pPr>
+            <a:r>
+              <a:rPr sz="2180" b="0" i="0">
+                <a:solidFill>
+                  <a:srgbClr val="111A20"/>
+                </a:solidFill>
+                <a:latin typeface="Athelas"/>
               </a:rPr>
-              <a:t>The model's output is a score, not a feeling. What a flagged year should feel like comes from people, not from the model.</a:t>
+              <a:t>Noéa connects machine intelligence to natural intelligence: a model learns the rhythm of a river or rainfall record and flags when it breaks.</a:t>
             </a:r>
           </a:p>
         </p:txBody>
@@ -7089,8 +6613,8 @@
         </p:nvCxnSpPr>
         <p:spPr>
           <a:xfrm>
-            <a:off x="914400" y="2331720"/>
-            <a:ext cx="3200400" cy="0"/>
+            <a:off x="914400" y="4160520"/>
+            <a:ext cx="1097280" cy="0"/>
           </a:xfrm>
           <a:prstGeom prst="line">
             <a:avLst/>
@@ -7124,8 +6648,8 @@
         </p:nvSpPr>
         <p:spPr>
           <a:xfrm>
-            <a:off x="914400" y="2606039"/>
-            <a:ext cx="3200400" cy="274320"/>
+            <a:off x="914400" y="4389120"/>
+            <a:ext cx="10362895" cy="1280160"/>
           </a:xfrm>
           <a:prstGeom prst="rect">
             <a:avLst/>
@@ -7138,15 +6662,19 @@
           </a:bodyPr>
           <a:lstStyle/>
           <a:p>
-            <a:pPr algn="l"/>
-            <a:r>
-              <a:rPr sz="1010" b="1" i="0" spc="140">
+            <a:pPr algn="l">
+              <a:lnSpc>
+                <a:spcPct val="115000"/>
+              </a:lnSpc>
+            </a:pPr>
+            <a:r>
+              <a:rPr sz="1850" b="0" i="1">
                 <a:solidFill>
                   <a:srgbClr val="00526F"/>
                 </a:solidFill>
-                <a:latin typeface="Frutiger"/>
+                <a:latin typeface="Athelas"/>
               </a:rPr>
-              <a:t>PERCEPTION</a:t>
+              <a:t>How people respond to that now has to be tested in human labs, with HCI methods. That is the research.</a:t>
             </a:r>
           </a:p>
         </p:txBody>
@@ -7159,8 +6687,8 @@
         </p:nvSpPr>
         <p:spPr>
           <a:xfrm>
-            <a:off x="914400" y="3063239"/>
-            <a:ext cx="3108960" cy="822960"/>
+            <a:off x="7162495" y="6309360"/>
+            <a:ext cx="3383280" cy="274320"/>
           </a:xfrm>
           <a:prstGeom prst="rect">
             <a:avLst/>
@@ -7173,479 +6701,22 @@
           </a:bodyPr>
           <a:lstStyle/>
           <a:p>
-            <a:pPr algn="l">
-              <a:lnSpc>
-                <a:spcPct val="105000"/>
-              </a:lnSpc>
-            </a:pPr>
-            <a:r>
-              <a:rPr sz="1850" b="0" i="0">
-                <a:solidFill>
-                  <a:srgbClr val="111A20"/>
-                </a:solidFill>
-                <a:latin typeface="Athelas"/>
-              </a:rPr>
-              <a:t>Do people feel what it intends?</a:t>
-            </a:r>
-          </a:p>
-        </p:txBody>
-      </p:sp>
-      <p:sp>
-        <p:nvSpPr>
-          <p:cNvPr id="7" name="TextBox 6"/>
-          <p:cNvSpPr txBox="1"/>
-          <p:nvPr/>
-        </p:nvSpPr>
-        <p:spPr>
-          <a:xfrm>
-            <a:off x="914400" y="3931920"/>
-            <a:ext cx="3108960" cy="1371600"/>
-          </a:xfrm>
-          <a:prstGeom prst="rect">
-            <a:avLst/>
-          </a:prstGeom>
-          <a:noFill/>
-        </p:spPr>
-        <p:txBody>
-          <a:bodyPr wrap="square" lIns="0" rIns="0" tIns="0" bIns="0" anchor="t">
-            <a:noAutofit/>
-          </a:bodyPr>
-          <a:lstStyle/>
-          <a:p>
-            <a:pPr algn="l">
-              <a:lnSpc>
-                <a:spcPct val="112000"/>
-              </a:lnSpc>
-            </a:pPr>
-            <a:r>
-              <a:rPr sz="1180" b="0" i="0">
-                <a:solidFill>
-                  <a:srgbClr val="5F6F78"/>
+            <a:pPr algn="r"/>
+            <a:r>
+              <a:rPr sz="1000" b="1" i="0">
+                <a:solidFill>
+                  <a:srgbClr val="00526F"/>
                 </a:solidFill>
                 <a:latin typeface="Frutiger"/>
               </a:rPr>
-              <a:t>The step from anomaly score to emotion is designed by hand. Nobody has tested whether viewers feel it.</a:t>
-            </a:r>
-          </a:p>
-        </p:txBody>
-      </p:sp>
-      <p:cxnSp>
-        <p:nvCxnSpPr>
-          <p:cNvPr id="8" name="Connector 7"/>
-          <p:cNvCxnSpPr/>
-          <p:nvPr/>
-        </p:nvCxnSpPr>
-        <p:spPr>
-          <a:xfrm>
-            <a:off x="4494276" y="2331720"/>
-            <a:ext cx="3200399" cy="0"/>
-          </a:xfrm>
-          <a:prstGeom prst="line">
-            <a:avLst/>
-          </a:prstGeom>
-          <a:ln w="38100">
-            <a:solidFill>
-              <a:srgbClr val="00526F"/>
-            </a:solidFill>
-          </a:ln>
-        </p:spPr>
-        <p:style>
-          <a:lnRef idx="2">
-            <a:schemeClr val="accent1"/>
-          </a:lnRef>
-          <a:fillRef idx="0">
-            <a:schemeClr val="accent1"/>
-          </a:fillRef>
-          <a:effectRef idx="1">
-            <a:schemeClr val="accent1"/>
-          </a:effectRef>
-          <a:fontRef idx="minor">
-            <a:schemeClr val="tx1"/>
-          </a:fontRef>
-        </p:style>
-      </p:cxnSp>
-      <p:sp>
-        <p:nvSpPr>
-          <p:cNvPr id="9" name="TextBox 8"/>
-          <p:cNvSpPr txBox="1"/>
-          <p:nvPr/>
-        </p:nvSpPr>
-        <p:spPr>
-          <a:xfrm>
-            <a:off x="4494276" y="2606039"/>
-            <a:ext cx="3200400" cy="274320"/>
-          </a:xfrm>
-          <a:prstGeom prst="rect">
-            <a:avLst/>
-          </a:prstGeom>
-          <a:noFill/>
-        </p:spPr>
-        <p:txBody>
-          <a:bodyPr wrap="square" lIns="0" rIns="0" tIns="0" bIns="0" anchor="t">
-            <a:noAutofit/>
-          </a:bodyPr>
-          <a:lstStyle/>
-          <a:p>
-            <a:pPr algn="l"/>
-            <a:r>
-              <a:rPr sz="1010" b="1" i="0" spc="140">
-                <a:solidFill>
-                  <a:srgbClr val="00526F"/>
-                </a:solidFill>
-                <a:latin typeface="Frutiger"/>
-              </a:rPr>
-              <a:t>UNDERSTANDING AND TRUST</a:t>
-            </a:r>
-          </a:p>
-        </p:txBody>
-      </p:sp>
-      <p:sp>
-        <p:nvSpPr>
-          <p:cNvPr id="10" name="TextBox 9"/>
-          <p:cNvSpPr txBox="1"/>
-          <p:nvPr/>
-        </p:nvSpPr>
-        <p:spPr>
-          <a:xfrm>
-            <a:off x="4494276" y="3063239"/>
-            <a:ext cx="3108960" cy="822960"/>
-          </a:xfrm>
-          <a:prstGeom prst="rect">
-            <a:avLst/>
-          </a:prstGeom>
-          <a:noFill/>
-        </p:spPr>
-        <p:txBody>
-          <a:bodyPr wrap="square" lIns="0" rIns="0" tIns="0" bIns="0" anchor="t">
-            <a:noAutofit/>
-          </a:bodyPr>
-          <a:lstStyle/>
-          <a:p>
-            <a:pPr algn="l">
-              <a:lnSpc>
-                <a:spcPct val="105000"/>
-              </a:lnSpc>
-            </a:pPr>
-            <a:r>
-              <a:rPr sz="1850" b="0" i="0">
-                <a:solidFill>
-                  <a:srgbClr val="111A20"/>
-                </a:solidFill>
-                <a:latin typeface="Athelas"/>
-              </a:rPr>
-              <a:t>Do they know what a flag means?</a:t>
-            </a:r>
-          </a:p>
-        </p:txBody>
-      </p:sp>
-      <p:sp>
-        <p:nvSpPr>
-          <p:cNvPr id="11" name="TextBox 10"/>
-          <p:cNvSpPr txBox="1"/>
-          <p:nvPr/>
-        </p:nvSpPr>
-        <p:spPr>
-          <a:xfrm>
-            <a:off x="4494276" y="3931920"/>
-            <a:ext cx="3108960" cy="1371600"/>
-          </a:xfrm>
-          <a:prstGeom prst="rect">
-            <a:avLst/>
-          </a:prstGeom>
-          <a:noFill/>
-        </p:spPr>
-        <p:txBody>
-          <a:bodyPr wrap="square" lIns="0" rIns="0" tIns="0" bIns="0" anchor="t">
-            <a:noAutofit/>
-          </a:bodyPr>
-          <a:lstStyle/>
-          <a:p>
-            <a:pPr algn="l">
-              <a:lnSpc>
-                <a:spcPct val="112000"/>
-              </a:lnSpc>
-            </a:pPr>
-            <a:r>
-              <a:rPr sz="1180" b="0" i="0">
-                <a:solidFill>
-                  <a:srgbClr val="5F6F78"/>
-                </a:solidFill>
-                <a:latin typeface="Frutiger"/>
-              </a:rPr>
-              <a:t>A flag is not the whole picture: a drought looks like an ordinary dry year to the model. Do people know what a missing flag does not tell them?</a:t>
-            </a:r>
-          </a:p>
-        </p:txBody>
-      </p:sp>
-      <p:cxnSp>
-        <p:nvCxnSpPr>
-          <p:cNvPr id="12" name="Connector 11"/>
-          <p:cNvCxnSpPr/>
-          <p:nvPr/>
-        </p:nvCxnSpPr>
-        <p:spPr>
-          <a:xfrm>
-            <a:off x="8074152" y="2331720"/>
-            <a:ext cx="3200400" cy="0"/>
-          </a:xfrm>
-          <a:prstGeom prst="line">
-            <a:avLst/>
-          </a:prstGeom>
-          <a:ln w="38100">
-            <a:solidFill>
-              <a:srgbClr val="00526F"/>
-            </a:solidFill>
-          </a:ln>
-        </p:spPr>
-        <p:style>
-          <a:lnRef idx="2">
-            <a:schemeClr val="accent1"/>
-          </a:lnRef>
-          <a:fillRef idx="0">
-            <a:schemeClr val="accent1"/>
-          </a:fillRef>
-          <a:effectRef idx="1">
-            <a:schemeClr val="accent1"/>
-          </a:effectRef>
-          <a:fontRef idx="minor">
-            <a:schemeClr val="tx1"/>
-          </a:fontRef>
-        </p:style>
-      </p:cxnSp>
-      <p:sp>
-        <p:nvSpPr>
-          <p:cNvPr id="13" name="TextBox 12"/>
-          <p:cNvSpPr txBox="1"/>
-          <p:nvPr/>
-        </p:nvSpPr>
-        <p:spPr>
-          <a:xfrm>
-            <a:off x="8074152" y="2606039"/>
-            <a:ext cx="3200400" cy="274320"/>
-          </a:xfrm>
-          <a:prstGeom prst="rect">
-            <a:avLst/>
-          </a:prstGeom>
-          <a:noFill/>
-        </p:spPr>
-        <p:txBody>
-          <a:bodyPr wrap="square" lIns="0" rIns="0" tIns="0" bIns="0" anchor="t">
-            <a:noAutofit/>
-          </a:bodyPr>
-          <a:lstStyle/>
-          <a:p>
-            <a:pPr algn="l"/>
-            <a:r>
-              <a:rPr sz="1010" b="1" i="0" spc="140">
-                <a:solidFill>
-                  <a:srgbClr val="00526F"/>
-                </a:solidFill>
-                <a:latin typeface="Frutiger"/>
-              </a:rPr>
-              <a:t>DECISION</a:t>
-            </a:r>
-          </a:p>
-        </p:txBody>
-      </p:sp>
-      <p:sp>
-        <p:nvSpPr>
-          <p:cNvPr id="14" name="TextBox 13"/>
-          <p:cNvSpPr txBox="1"/>
-          <p:nvPr/>
-        </p:nvSpPr>
-        <p:spPr>
-          <a:xfrm>
-            <a:off x="8074152" y="3063239"/>
-            <a:ext cx="3108960" cy="822960"/>
-          </a:xfrm>
-          <a:prstGeom prst="rect">
-            <a:avLst/>
-          </a:prstGeom>
-          <a:noFill/>
-        </p:spPr>
-        <p:txBody>
-          <a:bodyPr wrap="square" lIns="0" rIns="0" tIns="0" bIns="0" anchor="t">
-            <a:noAutofit/>
-          </a:bodyPr>
-          <a:lstStyle/>
-          <a:p>
-            <a:pPr algn="l">
-              <a:lnSpc>
-                <a:spcPct val="105000"/>
-              </a:lnSpc>
-            </a:pPr>
-            <a:r>
-              <a:rPr sz="1850" b="0" i="0">
-                <a:solidFill>
-                  <a:srgbClr val="111A20"/>
-                </a:solidFill>
-                <a:latin typeface="Athelas"/>
-              </a:rPr>
-              <a:t>Does it help them decide?</a:t>
-            </a:r>
-          </a:p>
-        </p:txBody>
-      </p:sp>
-      <p:sp>
-        <p:nvSpPr>
-          <p:cNvPr id="15" name="TextBox 14"/>
-          <p:cNvSpPr txBox="1"/>
-          <p:nvPr/>
-        </p:nvSpPr>
-        <p:spPr>
-          <a:xfrm>
-            <a:off x="8074152" y="3931920"/>
-            <a:ext cx="3108960" cy="1371600"/>
-          </a:xfrm>
-          <a:prstGeom prst="rect">
-            <a:avLst/>
-          </a:prstGeom>
-          <a:noFill/>
-        </p:spPr>
-        <p:txBody>
-          <a:bodyPr wrap="square" lIns="0" rIns="0" tIns="0" bIns="0" anchor="t">
-            <a:noAutofit/>
-          </a:bodyPr>
-          <a:lstStyle/>
-          <a:p>
-            <a:pPr algn="l">
-              <a:lnSpc>
-                <a:spcPct val="112000"/>
-              </a:lnSpc>
-            </a:pPr>
-            <a:r>
-              <a:rPr sz="1180" b="0" i="0">
-                <a:solidFill>
-                  <a:srgbClr val="5F6F78"/>
-                </a:solidFill>
-                <a:latin typeface="Frutiger"/>
-              </a:rPr>
-              <a:t>Does an XR and sound experience change how decision-makers understand a river, compared with a standard chart?</a:t>
-            </a:r>
-          </a:p>
-        </p:txBody>
-      </p:sp>
-      <p:cxnSp>
-        <p:nvCxnSpPr>
-          <p:cNvPr id="16" name="Connector 15"/>
-          <p:cNvCxnSpPr/>
-          <p:nvPr/>
-        </p:nvCxnSpPr>
-        <p:spPr>
-          <a:xfrm>
-            <a:off x="914400" y="5230368"/>
-            <a:ext cx="10362895" cy="0"/>
-          </a:xfrm>
-          <a:prstGeom prst="line">
-            <a:avLst/>
-          </a:prstGeom>
-          <a:ln w="15875">
-            <a:solidFill>
-              <a:srgbClr val="D3DDE2"/>
-            </a:solidFill>
-          </a:ln>
-        </p:spPr>
-        <p:style>
-          <a:lnRef idx="2">
-            <a:schemeClr val="accent1"/>
-          </a:lnRef>
-          <a:fillRef idx="0">
-            <a:schemeClr val="accent1"/>
-          </a:fillRef>
-          <a:effectRef idx="1">
-            <a:schemeClr val="accent1"/>
-          </a:effectRef>
-          <a:fontRef idx="minor">
-            <a:schemeClr val="tx1"/>
-          </a:fontRef>
-        </p:style>
-      </p:cxnSp>
-      <p:sp>
-        <p:nvSpPr>
-          <p:cNvPr id="17" name="TextBox 16"/>
-          <p:cNvSpPr txBox="1"/>
-          <p:nvPr/>
-        </p:nvSpPr>
-        <p:spPr>
-          <a:xfrm>
-            <a:off x="914400" y="5376672"/>
-            <a:ext cx="10362895" cy="731520"/>
-          </a:xfrm>
-          <a:prstGeom prst="rect">
-            <a:avLst/>
-          </a:prstGeom>
-          <a:noFill/>
-        </p:spPr>
-        <p:txBody>
-          <a:bodyPr wrap="square" lIns="0" rIns="0" tIns="0" bIns="0" anchor="t">
-            <a:noAutofit/>
-          </a:bodyPr>
-          <a:lstStyle/>
-          <a:p>
-            <a:pPr algn="l">
-              <a:lnSpc>
-                <a:spcPct val="110000"/>
-              </a:lnSpc>
-            </a:pPr>
-            <a:r>
-              <a:rPr sz="1180" b="1" i="0" spc="100">
-                <a:solidFill>
-                  <a:srgbClr val="00526F"/>
-                </a:solidFill>
-                <a:latin typeface="Frutiger"/>
-              </a:rPr>
-              <a:t>Next  </a:t>
-            </a:r>
-            <a:r>
-              <a:rPr sz="1510" b="0" i="0">
-                <a:solidFill>
-                  <a:srgbClr val="111A20"/>
-                </a:solidFill>
-                <a:latin typeface="Athelas"/>
-              </a:rPr>
-              <a:t>learn the mapping from human responses, and test it with the people who make water decisions.</a:t>
-            </a:r>
-          </a:p>
-        </p:txBody>
-      </p:sp>
-      <p:sp>
-        <p:nvSpPr>
-          <p:cNvPr id="18" name="TextBox 17"/>
-          <p:cNvSpPr txBox="1"/>
-          <p:nvPr/>
-        </p:nvSpPr>
-        <p:spPr>
-          <a:xfrm>
-            <a:off x="7162495" y="6309360"/>
-            <a:ext cx="3383280" cy="274320"/>
-          </a:xfrm>
-          <a:prstGeom prst="rect">
-            <a:avLst/>
-          </a:prstGeom>
-          <a:noFill/>
-        </p:spPr>
-        <p:txBody>
-          <a:bodyPr wrap="square" lIns="0" rIns="0" tIns="0" bIns="0" anchor="t">
-            <a:noAutofit/>
-          </a:bodyPr>
-          <a:lstStyle/>
-          <a:p>
-            <a:pPr algn="r"/>
-            <a:r>
-              <a:rPr sz="1000" b="1" i="0">
-                <a:solidFill>
-                  <a:srgbClr val="00526F"/>
-                </a:solidFill>
-                <a:latin typeface="Frutiger"/>
-              </a:rPr>
-              <a:t>github.com/qintheory/noea</a:t>
+              <a:t>meetingofwaters.org/noea</a:t>
             </a:r>
           </a:p>
         </p:txBody>
       </p:sp>
       <p:pic>
         <p:nvPicPr>
-          <p:cNvPr id="19" name="Picture 18" descr="logo.png"/>
+          <p:cNvPr id="7" name="Picture 6" descr="logo.png"/>
           <p:cNvPicPr>
             <a:picLocks noChangeAspect="1"/>
           </p:cNvPicPr>
@@ -7669,7 +6740,7 @@
       </p:pic>
       <p:sp>
         <p:nvSpPr>
-          <p:cNvPr id="20" name="TextBox 19"/>
+          <p:cNvPr id="8" name="TextBox 7"/>
           <p:cNvSpPr txBox="1"/>
           <p:nvPr/>
         </p:nvSpPr>

</xml_diff>

<commit_message>
Rework the introduction deck: one text source, Russell cited, new cover and visuals
- Deck text now lives in docs/source/content.py; the pptx, PDF and HTML are built from it
  (docs/source also holds the builders, assets, chart and background scripts).
- Cover: noéa wordmark, Meeting of Waters logo top right; cover ECG as MP4 and GIF.
- Copy made more rigorous and consistent (diagnostic layer / curatorial layer, valence and
  arousal after Russell 1980 as adopted in Issue 4, limits stated, XR prototypes).
- Slide 6 is an anomaly ribbon redrawn from the pipeline; the drought-detection claim in the
  README is corrected to "does not reliably flag droughts".
- HTML renamed docs/introduction.html.

Co-Authored-By: Claude Sonnet 5.5 <noreply@anthropic.com>
</commit_message>
<xml_diff>
--- a/docs/noea-introduction-animated.pptx
+++ b/docs/noea-introduction-animated.pptx
@@ -508,7 +508,7 @@
           <a:lstStyle/>
           <a:p>
             <a:r>
-              <a:t>Noéa translates long hydrological records into something people can experience. The ECG below is real data: Hong Kong's annual peak daily rainfall, 1884 to 2025, one beat per year.</a:t>
+              <a:t>Noéa translates long hydrological records into something people can experience. The line on screen is real data: Hong Kong's annual peak daily rainfall, 1884 to 2025, one beat per year.</a:t>
             </a:r>
           </a:p>
         </p:txBody>
@@ -578,7 +578,7 @@
           <a:lstStyle/>
           <a:p>
             <a:r>
-              <a:t>More stations measure more rain and more rivers every year. The data can tell us a river is changing. What it rarely does is make anyone feel it, and without that, decisions stall.</a:t>
+              <a:t>Long records already show that rivers and rainfall are changing, as charts and indices. Noéa is an attempt to translate that into something people can perceive. Whether it works is the research question at the end.</a:t>
             </a:r>
           </a:p>
         </p:txBody>
@@ -648,7 +648,7 @@
           <a:lstStyle/>
           <a:p>
             <a:r>
-              <a:t>Noéa translates hydrological records into something people can experience. It reads a rainfall or river record the way a cardiologist reads an ECG, looking for rhythm, memory and shock. From that it derives two affective values, valence and arousal: how pleasant or distressing, and how activated. Those are designed to feed into an XR experience.</a:t>
+              <a:t>Noéa reads a rainfall or river record the way an ECG is read, in the sense of Issue 3: rhythm, memory, shock. From the diagnostics it derives two affective values, valence and arousal, from Russell's circumplex model of affect: how pleasant or unpleasant, and how calm or activated. They are design decisions about how a result should feel, not properties of the water. Two XR prototypes exist; the next step is to connect them to the analysis and to real scenarios.</a:t>
             </a:r>
           </a:p>
         </p:txBody>
@@ -718,7 +718,7 @@
           <a:lstStyle/>
           <a:p>
             <a:r>
-              <a:t>Our method is built to be universal, where each record fits its own model on its own history. Public records of Hong Kong and the Rhine are the two we've tested. And another rainfall or river record can go through the same pipeline.</a:t>
+              <a:t>The method is designed to be universal: every record fits its own model on its own history. Hong Kong rainfall and the Rhine and alpine rivers are the only two records run so far. Another rainfall or river record is designed to pass through the same pipeline, but that has not been tested.</a:t>
             </a:r>
           </a:p>
         </p:txBody>
@@ -788,7 +788,7 @@
           <a:lstStyle/>
           <a:p>
             <a:r>
-              <a:t>There are two layers, kept deliberately apart. The first diagnostic layer is plain science: for Hong Kong, over a century of daily rainfall; for the Rhine and its alpine tributaries, eight stations of discharge. The second layer is curatorial, which is currently kept separate from the measurements, so the feeling would be redesigned without changing any of the science.</a:t>
+              <a:t>There are two layers, kept apart on purpose. The diagnostic layer is plain science: Hong Kong's daily rainfall since 1884, and discharge at eight Rhine and alpine stations. The curatorial layer decides how a result should feel. It is separate code, so the feeling can be redesigned without changing any science. Its output is valence and arousal, chosen by design and checked against named historical events. It has not been tested with people.</a:t>
             </a:r>
           </a:p>
         </p:txBody>
@@ -858,7 +858,7 @@
           <a:lstStyle/>
           <a:p>
             <a:r>
-              <a:t>Machine learning has one job so far: finding unusual years. For each record, an unsupervised model learns what a typical year looks like, then scores how badly each year fails to fit.</a:t>
+              <a:t>Machine learning has one job so far: finding unusual years. For each record an unsupervised model learns what a typical year looks like, then scores how badly each year fails to fit. The ribbon is the one from Issue 6, but coloured by the model's score instead of by discharge. At Lustenau the highest-scoring year is the August 2005 flood and at Köln and Lobith the Christmas 1993 flood; none was told to the model. At Basel it is 1972, a drought year in Issue 6. It is not a drought detector, though: 1976 ranks third of 70 at Lustenau but 187th of 208 at Köln, and the 1995 Köln flood ranks 101st. In Hong Kong the same model ranks 1926 seventh and 2023 nineteenth of 134 complete years, and the 1963 drought 98th. It flags unusual combinations of features, not every extreme. On the Aare at Thun, not shown, the highest year is the May 1999 Swiss flood.</a:t>
             </a:r>
           </a:p>
         </p:txBody>
@@ -928,7 +928,7 @@
           <a:lstStyle/>
           <a:p>
             <a:r>
-              <a:t>Noéa connects machine intelligence to natural intelligence: a model learns the rhythm of a river or rainfall record and flags when it breaks. How people respond to that now has to be tested in human labs, with HCI methods. That is the research.</a:t>
+              <a:t>Noéa connects machine intelligence to natural intelligence: a model learns the rhythm of a river or rainfall record and flags the years that break it. What nobody has tested is whether people feel what the system intends. That has to be studied in human labs, with HCI methods. That is the research.</a:t>
             </a:r>
           </a:p>
         </p:txBody>
@@ -3942,114 +3942,9 @@
         <p:nvPr/>
       </p:nvGrpSpPr>
       <p:grpSpPr/>
-      <p:sp>
-        <p:nvSpPr>
-          <p:cNvPr id="2" name="TextBox 1"/>
-          <p:cNvSpPr txBox="1"/>
-          <p:nvPr/>
-        </p:nvSpPr>
-        <p:spPr>
-          <a:xfrm>
-            <a:off x="914400" y="548640"/>
-            <a:ext cx="8229600" cy="1737360"/>
-          </a:xfrm>
-          <a:prstGeom prst="rect">
-            <a:avLst/>
-          </a:prstGeom>
-          <a:noFill/>
-        </p:spPr>
-        <p:txBody>
-          <a:bodyPr wrap="square" lIns="0" rIns="0" tIns="0" bIns="0" anchor="t">
-            <a:noAutofit/>
-          </a:bodyPr>
-          <a:lstStyle/>
-          <a:p>
-            <a:pPr algn="l"/>
-            <a:r>
-              <a:rPr sz="9410" b="0" i="0">
-                <a:solidFill>
-                  <a:srgbClr val="111A20"/>
-                </a:solidFill>
-                <a:latin typeface="Athelas"/>
-              </a:rPr>
-              <a:t>Noéa</a:t>
-            </a:r>
-          </a:p>
-        </p:txBody>
-      </p:sp>
-      <p:sp>
-        <p:nvSpPr>
-          <p:cNvPr id="3" name="TextBox 2"/>
-          <p:cNvSpPr txBox="1"/>
-          <p:nvPr/>
-        </p:nvSpPr>
-        <p:spPr>
-          <a:xfrm>
-            <a:off x="914400" y="2194560"/>
-            <a:ext cx="10362895" cy="640080"/>
-          </a:xfrm>
-          <a:prstGeom prst="rect">
-            <a:avLst/>
-          </a:prstGeom>
-          <a:noFill/>
-        </p:spPr>
-        <p:txBody>
-          <a:bodyPr wrap="square" lIns="0" rIns="0" tIns="0" bIns="0" anchor="t">
-            <a:noAutofit/>
-          </a:bodyPr>
-          <a:lstStyle/>
-          <a:p>
-            <a:pPr algn="l"/>
-            <a:r>
-              <a:rPr sz="2520" b="0" i="1">
-                <a:solidFill>
-                  <a:srgbClr val="00526F"/>
-                </a:solidFill>
-                <a:latin typeface="Athelas"/>
-              </a:rPr>
-              <a:t>Reading water as rhythm, memory and mood</a:t>
-            </a:r>
-          </a:p>
-        </p:txBody>
-      </p:sp>
-      <p:sp>
-        <p:nvSpPr>
-          <p:cNvPr id="4" name="TextBox 3"/>
-          <p:cNvSpPr txBox="1"/>
-          <p:nvPr/>
-        </p:nvSpPr>
-        <p:spPr>
-          <a:xfrm>
-            <a:off x="914400" y="2788920"/>
-            <a:ext cx="10362895" cy="365760"/>
-          </a:xfrm>
-          <a:prstGeom prst="rect">
-            <a:avLst/>
-          </a:prstGeom>
-          <a:noFill/>
-        </p:spPr>
-        <p:txBody>
-          <a:bodyPr wrap="square" lIns="0" rIns="0" tIns="0" bIns="0" anchor="t">
-            <a:noAutofit/>
-          </a:bodyPr>
-          <a:lstStyle/>
-          <a:p>
-            <a:pPr algn="l"/>
-            <a:r>
-              <a:rPr sz="1340" b="0" i="0">
-                <a:solidFill>
-                  <a:srgbClr val="5F6F78"/>
-                </a:solidFill>
-                <a:latin typeface="Frutiger"/>
-              </a:rPr>
-              <a:t>Affective computing for water systems</a:t>
-            </a:r>
-          </a:p>
-        </p:txBody>
-      </p:sp>
       <p:pic>
         <p:nvPicPr>
-          <p:cNvPr id="5" name="Picture 4" descr="ecg_row1.png"/>
+          <p:cNvPr id="2" name="Picture 1" descr="noea_wordmark.png"/>
           <p:cNvPicPr>
             <a:picLocks noChangeAspect="1"/>
           </p:cNvPicPr>
@@ -4063,8 +3958,8 @@
         </p:blipFill>
         <p:spPr>
           <a:xfrm>
-            <a:off x="914400" y="3840480"/>
-            <a:ext cx="10362895" cy="1342645"/>
+            <a:off x="914400" y="777240"/>
+            <a:ext cx="3188601" cy="1051560"/>
           </a:xfrm>
           <a:prstGeom prst="rect">
             <a:avLst/>
@@ -4073,14 +3968,14 @@
       </p:pic>
       <p:sp>
         <p:nvSpPr>
-          <p:cNvPr id="6" name="TextBox 5"/>
+          <p:cNvPr id="3" name="TextBox 2"/>
           <p:cNvSpPr txBox="1"/>
           <p:nvPr/>
         </p:nvSpPr>
         <p:spPr>
           <a:xfrm>
-            <a:off x="914400" y="5897880"/>
-            <a:ext cx="10362895" cy="274320"/>
+            <a:off x="914400" y="2194560"/>
+            <a:ext cx="10362895" cy="640080"/>
           </a:xfrm>
           <a:prstGeom prst="rect">
             <a:avLst/>
@@ -4095,20 +3990,55 @@
           <a:p>
             <a:pPr algn="l"/>
             <a:r>
-              <a:rPr sz="1000" b="0" i="0">
+              <a:rPr sz="2520" b="0" i="1">
+                <a:solidFill>
+                  <a:srgbClr val="00526F"/>
+                </a:solidFill>
+                <a:latin typeface="Athelas"/>
+              </a:rPr>
+              <a:t>Reading water as rhythm, memory and mood</a:t>
+            </a:r>
+          </a:p>
+        </p:txBody>
+      </p:sp>
+      <p:sp>
+        <p:nvSpPr>
+          <p:cNvPr id="4" name="TextBox 3"/>
+          <p:cNvSpPr txBox="1"/>
+          <p:nvPr/>
+        </p:nvSpPr>
+        <p:spPr>
+          <a:xfrm>
+            <a:off x="914400" y="2788920"/>
+            <a:ext cx="10362895" cy="365760"/>
+          </a:xfrm>
+          <a:prstGeom prst="rect">
+            <a:avLst/>
+          </a:prstGeom>
+          <a:noFill/>
+        </p:spPr>
+        <p:txBody>
+          <a:bodyPr wrap="square" lIns="0" rIns="0" tIns="0" bIns="0" anchor="t">
+            <a:noAutofit/>
+          </a:bodyPr>
+          <a:lstStyle/>
+          <a:p>
+            <a:pPr algn="l"/>
+            <a:r>
+              <a:rPr sz="1340" b="0" i="0">
                 <a:solidFill>
                   <a:srgbClr val="5F6F78"/>
                 </a:solidFill>
                 <a:latin typeface="Frutiger"/>
               </a:rPr>
-              <a:t>Hong Kong, 1884–2025: one beat per year. Height is the year's peak daily rainfall; spacing is the time since the previous peak.</a:t>
+              <a:t>Affective computing for water systems</a:t>
             </a:r>
           </a:p>
         </p:txBody>
       </p:sp>
       <p:pic>
         <p:nvPicPr>
-          <p:cNvPr id="7" name="Picture 6" descr="logo.png"/>
+          <p:cNvPr id="5" name="Picture 4" descr="ecg_row1.png"/>
           <p:cNvPicPr>
             <a:picLocks noChangeAspect="1"/>
           </p:cNvPicPr>
@@ -4122,7 +4052,66 @@
         </p:blipFill>
         <p:spPr>
           <a:xfrm>
-            <a:off x="914400" y="6236208"/>
+            <a:off x="914400" y="3840480"/>
+            <a:ext cx="10362895" cy="1342645"/>
+          </a:xfrm>
+          <a:prstGeom prst="rect">
+            <a:avLst/>
+          </a:prstGeom>
+        </p:spPr>
+      </p:pic>
+      <p:sp>
+        <p:nvSpPr>
+          <p:cNvPr id="6" name="TextBox 5"/>
+          <p:cNvSpPr txBox="1"/>
+          <p:nvPr/>
+        </p:nvSpPr>
+        <p:spPr>
+          <a:xfrm>
+            <a:off x="914400" y="5897880"/>
+            <a:ext cx="10362895" cy="274320"/>
+          </a:xfrm>
+          <a:prstGeom prst="rect">
+            <a:avLst/>
+          </a:prstGeom>
+          <a:noFill/>
+        </p:spPr>
+        <p:txBody>
+          <a:bodyPr wrap="square" lIns="0" rIns="0" tIns="0" bIns="0" anchor="t">
+            <a:noAutofit/>
+          </a:bodyPr>
+          <a:lstStyle/>
+          <a:p>
+            <a:pPr algn="l"/>
+            <a:r>
+              <a:rPr sz="1000" b="0" i="0">
+                <a:solidFill>
+                  <a:srgbClr val="5F6F78"/>
+                </a:solidFill>
+                <a:latin typeface="Frutiger"/>
+              </a:rPr>
+              <a:t>Hong Kong, 1884–2025: one beat per year. Height is the year's peak daily rainfall; spacing is the time since the previous peak.</a:t>
+            </a:r>
+          </a:p>
+        </p:txBody>
+      </p:sp>
+      <p:pic>
+        <p:nvPicPr>
+          <p:cNvPr id="7" name="Picture 6" descr="logo.png"/>
+          <p:cNvPicPr>
+            <a:picLocks noChangeAspect="1"/>
+          </p:cNvPicPr>
+          <p:nvPr/>
+        </p:nvPicPr>
+        <p:blipFill>
+          <a:blip r:embed="rId5"/>
+          <a:stretch>
+            <a:fillRect/>
+          </a:stretch>
+        </p:blipFill>
+        <p:spPr>
+          <a:xfrm>
+            <a:off x="9156947" y="868680"/>
             <a:ext cx="2120348" cy="292608"/>
           </a:xfrm>
           <a:prstGeom prst="rect">
@@ -4242,9 +4231,33 @@
         <p:nvPr/>
       </p:nvGrpSpPr>
       <p:grpSpPr/>
-      <p:sp>
-        <p:nvSpPr>
-          <p:cNvPr id="2" name="TextBox 1"/>
+      <p:pic>
+        <p:nvPicPr>
+          <p:cNvPr id="2" name="Picture 1" descr="slide2_decor.jpg"/>
+          <p:cNvPicPr>
+            <a:picLocks noChangeAspect="1"/>
+          </p:cNvPicPr>
+          <p:nvPr/>
+        </p:nvPicPr>
+        <p:blipFill>
+          <a:blip r:embed="rId3"/>
+          <a:stretch>
+            <a:fillRect/>
+          </a:stretch>
+        </p:blipFill>
+        <p:spPr>
+          <a:xfrm>
+            <a:off x="7500823" y="0"/>
+            <a:ext cx="4690872" cy="6858000"/>
+          </a:xfrm>
+          <a:prstGeom prst="rect">
+            <a:avLst/>
+          </a:prstGeom>
+        </p:spPr>
+      </p:pic>
+      <p:sp>
+        <p:nvSpPr>
+          <p:cNvPr id="3" name="TextBox 2"/>
           <p:cNvSpPr txBox="1"/>
           <p:nvPr/>
         </p:nvSpPr>
@@ -4276,14 +4289,30 @@
                 </a:solidFill>
                 <a:latin typeface="Athelas"/>
               </a:rPr>
-              <a:t>Data can show that a river is changing. It rarely makes anyone feel it.</a:t>
+              <a:t>Data can show that a river is changing.</a:t>
+            </a:r>
+          </a:p>
+          <a:p>
+            <a:pPr algn="l">
+              <a:lnSpc>
+                <a:spcPct val="110000"/>
+              </a:lnSpc>
+            </a:pPr>
+            <a:r>
+              <a:rPr sz="3860" b="0" i="0">
+                <a:solidFill>
+                  <a:srgbClr val="111A20"/>
+                </a:solidFill>
+                <a:latin typeface="Athelas"/>
+              </a:rPr>
+              <a:t>It rarely makes anyone feel it.</a:t>
             </a:r>
           </a:p>
         </p:txBody>
       </p:sp>
       <p:cxnSp>
         <p:nvCxnSpPr>
-          <p:cNvPr id="3" name="Connector 2"/>
+          <p:cNvPr id="4" name="Connector 3"/>
           <p:cNvCxnSpPr/>
           <p:nvPr/>
         </p:nvCxnSpPr>
@@ -4318,7 +4347,7 @@
       </p:cxnSp>
       <p:sp>
         <p:nvSpPr>
-          <p:cNvPr id="4" name="TextBox 3"/>
+          <p:cNvPr id="5" name="TextBox 4"/>
           <p:cNvSpPr txBox="1"/>
           <p:nvPr/>
         </p:nvSpPr>
@@ -4350,21 +4379,30 @@
                 </a:solidFill>
                 <a:latin typeface="Athelas"/>
               </a:rPr>
-              <a:t>Noéa works in the missing layer: turning measurement into meaning people can experience.</a:t>
+              <a:t>Noéa</a:t>
+            </a:r>
+            <a:r>
+              <a:rPr sz="1850" b="0" i="1">
+                <a:solidFill>
+                  <a:srgbClr val="00526F"/>
+                </a:solidFill>
+                <a:latin typeface="Athelas"/>
+              </a:rPr>
+              <a:t> works in the missing layer: turning measurement into meaning people can experience.</a:t>
             </a:r>
           </a:p>
         </p:txBody>
       </p:sp>
       <p:pic>
         <p:nvPicPr>
-          <p:cNvPr id="5" name="Picture 4" descr="logo.png"/>
+          <p:cNvPr id="6" name="Picture 5" descr="logo.png"/>
           <p:cNvPicPr>
             <a:picLocks noChangeAspect="1"/>
           </p:cNvPicPr>
           <p:nvPr/>
         </p:nvPicPr>
         <p:blipFill>
-          <a:blip r:embed="rId3"/>
+          <a:blip r:embed="rId4"/>
           <a:stretch>
             <a:fillRect/>
           </a:stretch>
@@ -4381,7 +4419,7 @@
       </p:pic>
       <p:sp>
         <p:nvSpPr>
-          <p:cNvPr id="6" name="TextBox 5"/>
+          <p:cNvPr id="7" name="TextBox 6"/>
           <p:cNvSpPr txBox="1"/>
           <p:nvPr/>
         </p:nvSpPr>
@@ -4625,7 +4663,7 @@
                 </a:solidFill>
                 <a:latin typeface="Frutiger"/>
               </a:rPr>
-              <a:t>Daily rainfall or river discharge, covering decades to centuries.</a:t>
+              <a:t>Daily rainfall or river discharge, covering decades to two centuries.</a:t>
             </a:r>
           </a:p>
         </p:txBody>
@@ -4734,7 +4772,7 @@
                 </a:solidFill>
                 <a:latin typeface="Athelas"/>
               </a:rPr>
-              <a:t>Diagnostics</a:t>
+              <a:t>ECG-inspired diagnostics</a:t>
             </a:r>
           </a:p>
         </p:txBody>
@@ -4776,7 +4814,26 @@
                 </a:solidFill>
                 <a:latin typeface="Frutiger"/>
               </a:rPr>
-              <a:t>Peaks and the gaps between them, return periods, flow duration, recession, the seasonal cycle.</a:t>
+              <a:t>Rainfall: annual peaks, the gaps between them, return periods.</a:t>
+            </a:r>
+          </a:p>
+          <a:p>
+            <a:pPr algn="l">
+              <a:lnSpc>
+                <a:spcPct val="112000"/>
+              </a:lnSpc>
+              <a:spcAft>
+                <a:spcPts val="700"/>
+              </a:spcAft>
+            </a:pPr>
+            <a:r>
+              <a:rPr sz="1220" b="0" i="0">
+                <a:solidFill>
+                  <a:srgbClr val="5F6F78"/>
+                </a:solidFill>
+                <a:latin typeface="Frutiger"/>
+              </a:rPr>
+              <a:t>Rivers: flow duration, recession, the seasonal cycle.</a:t>
             </a:r>
           </a:p>
         </p:txBody>
@@ -4927,7 +4984,7 @@
                 </a:solidFill>
                 <a:latin typeface="Frutiger"/>
               </a:rPr>
-              <a:t>Valence: pleasant to distressing.</a:t>
+              <a:t>Valence: pleasant to unpleasant.</a:t>
             </a:r>
           </a:p>
           <a:p>
@@ -4965,7 +5022,7 @@
                 </a:solidFill>
                 <a:latin typeface="Frutiger"/>
               </a:rPr>
-              <a:t>Alongside four physical readouts: size, glow, texture, tempo.</a:t>
+              <a:t>Set by design in the curatorial layer.</a:t>
             </a:r>
           </a:p>
         </p:txBody>
@@ -5116,14 +5173,86 @@
                 </a:solidFill>
                 <a:latin typeface="Frutiger"/>
               </a:rPr>
-              <a:t>Designed to feed an immersive XR experience. The output format is still provisional.</a:t>
+              <a:t>Two XR prototypes exist.</a:t>
+            </a:r>
+          </a:p>
+          <a:p>
+            <a:pPr algn="l">
+              <a:lnSpc>
+                <a:spcPct val="112000"/>
+              </a:lnSpc>
+              <a:spcAft>
+                <a:spcPts val="700"/>
+              </a:spcAft>
+            </a:pPr>
+            <a:r>
+              <a:rPr sz="1220" b="0" i="0">
+                <a:solidFill>
+                  <a:srgbClr val="5F6F78"/>
+                </a:solidFill>
+                <a:latin typeface="Frutiger"/>
+              </a:rPr>
+              <a:t>Next: connect them to the analysis and to real scenarios.</a:t>
+            </a:r>
+          </a:p>
+        </p:txBody>
+      </p:sp>
+      <p:sp>
+        <p:nvSpPr>
+          <p:cNvPr id="19" name="TextBox 18"/>
+          <p:cNvSpPr txBox="1"/>
+          <p:nvPr/>
+        </p:nvSpPr>
+        <p:spPr>
+          <a:xfrm>
+            <a:off x="914400" y="5760720"/>
+            <a:ext cx="10362895" cy="274320"/>
+          </a:xfrm>
+          <a:prstGeom prst="rect">
+            <a:avLst/>
+          </a:prstGeom>
+          <a:noFill/>
+        </p:spPr>
+        <p:txBody>
+          <a:bodyPr wrap="square" lIns="0" rIns="0" tIns="0" bIns="0" anchor="t">
+            <a:noAutofit/>
+          </a:bodyPr>
+          <a:lstStyle/>
+          <a:p>
+            <a:pPr algn="l"/>
+            <a:r>
+              <a:rPr sz="1000" b="0" i="0">
+                <a:solidFill>
+                  <a:srgbClr val="5F6F78"/>
+                </a:solidFill>
+                <a:latin typeface="Frutiger"/>
+              </a:rPr>
+              <a:t>Valence and arousal follow Russell's circumplex model of affect: Russell, J. A. (1980), Journal of Personality and Social Psychology, 39(6), 1161–1178. Adopted in </a:t>
+            </a:r>
+            <a:r>
+              <a:rPr sz="1000" b="0" i="1">
+                <a:solidFill>
+                  <a:srgbClr val="5F6F78"/>
+                </a:solidFill>
+                <a:latin typeface="Frutiger"/>
+              </a:rPr>
+              <a:t>Noéa</a:t>
+            </a:r>
+            <a:r>
+              <a:rPr sz="1000" b="0" i="0">
+                <a:solidFill>
+                  <a:srgbClr val="5F6F78"/>
+                </a:solidFill>
+                <a:latin typeface="Frutiger"/>
+              </a:rPr>
+              <a:t> Issue 4.</a:t>
             </a:r>
           </a:p>
         </p:txBody>
       </p:sp>
       <p:pic>
         <p:nvPicPr>
-          <p:cNvPr id="19" name="Picture 18" descr="logo.png"/>
+          <p:cNvPr id="20" name="Picture 19" descr="logo.png"/>
           <p:cNvPicPr>
             <a:picLocks noChangeAspect="1"/>
           </p:cNvPicPr>
@@ -5147,7 +5276,7 @@
       </p:pic>
       <p:sp>
         <p:nvSpPr>
-          <p:cNvPr id="20" name="TextBox 19"/>
+          <p:cNvPr id="21" name="TextBox 20"/>
           <p:cNvSpPr txBox="1"/>
           <p:nvPr/>
         </p:nvSpPr>
@@ -5240,7 +5369,7 @@
                 </a:solidFill>
                 <a:latin typeface="Athelas"/>
               </a:rPr>
-              <a:t>Built to be universal</a:t>
+              <a:t>Designed to be universal</a:t>
             </a:r>
           </a:p>
         </p:txBody>
@@ -5279,7 +5408,7 @@
                 </a:solidFill>
                 <a:latin typeface="Athelas"/>
               </a:rPr>
-              <a:t>Each record fits its own model on its own history. Another rainfall or river record can go through the same pipeline.</a:t>
+              <a:t>Each record fits its own model on its own history. Other long rainfall or river records are designed to go through the same pipeline.</a:t>
             </a:r>
           </a:p>
         </p:txBody>
@@ -5292,7 +5421,7 @@
         </p:nvCxnSpPr>
         <p:spPr>
           <a:xfrm>
-            <a:off x="914400" y="3703320"/>
+            <a:off x="914400" y="3291840"/>
             <a:ext cx="10362895" cy="0"/>
           </a:xfrm>
           <a:prstGeom prst="line">
@@ -5327,7 +5456,7 @@
         </p:nvSpPr>
         <p:spPr>
           <a:xfrm>
-            <a:off x="914400" y="3886200"/>
+            <a:off x="914400" y="3474720"/>
             <a:ext cx="3840480" cy="457200"/>
           </a:xfrm>
           <a:prstGeom prst="rect">
@@ -5362,7 +5491,7 @@
         </p:nvSpPr>
         <p:spPr>
           <a:xfrm>
-            <a:off x="4937760" y="3950208"/>
+            <a:off x="4937760" y="3538728"/>
             <a:ext cx="6339535" cy="457200"/>
           </a:xfrm>
           <a:prstGeom prst="rect">
@@ -5397,7 +5526,7 @@
         </p:nvCxnSpPr>
         <p:spPr>
           <a:xfrm>
-            <a:off x="914400" y="4434840"/>
+            <a:off x="914400" y="4023360"/>
             <a:ext cx="10362895" cy="0"/>
           </a:xfrm>
           <a:prstGeom prst="line">
@@ -5432,7 +5561,7 @@
         </p:nvSpPr>
         <p:spPr>
           <a:xfrm>
-            <a:off x="914400" y="4617720"/>
+            <a:off x="914400" y="4206240"/>
             <a:ext cx="3840480" cy="457200"/>
           </a:xfrm>
           <a:prstGeom prst="rect">
@@ -5467,7 +5596,7 @@
         </p:nvSpPr>
         <p:spPr>
           <a:xfrm>
-            <a:off x="4937760" y="4681727"/>
+            <a:off x="4937760" y="4270248"/>
             <a:ext cx="6339535" cy="457200"/>
           </a:xfrm>
           <a:prstGeom prst="rect">
@@ -5502,7 +5631,7 @@
         </p:nvCxnSpPr>
         <p:spPr>
           <a:xfrm>
-            <a:off x="914400" y="5166359"/>
+            <a:off x="914400" y="4754880"/>
             <a:ext cx="10362895" cy="0"/>
           </a:xfrm>
           <a:prstGeom prst="line">
@@ -5537,7 +5666,7 @@
         </p:nvSpPr>
         <p:spPr>
           <a:xfrm>
-            <a:off x="914400" y="5349240"/>
+            <a:off x="914400" y="4937760"/>
             <a:ext cx="3840480" cy="457200"/>
           </a:xfrm>
           <a:prstGeom prst="rect">
@@ -5572,7 +5701,7 @@
         </p:nvSpPr>
         <p:spPr>
           <a:xfrm>
-            <a:off x="4937760" y="5413248"/>
+            <a:off x="4937760" y="5001768"/>
             <a:ext cx="6339535" cy="457200"/>
           </a:xfrm>
           <a:prstGeom prst="rect">
@@ -5594,7 +5723,7 @@
                 </a:solidFill>
                 <a:latin typeface="Frutiger"/>
               </a:rPr>
-              <a:t>Not yet run. Tested on two records so far.</a:t>
+              <a:t>TBA</a:t>
             </a:r>
           </a:p>
         </p:txBody>
@@ -5788,7 +5917,7 @@
                 </a:solidFill>
                 <a:latin typeface="Frutiger"/>
               </a:rPr>
-              <a:t>PLAIN SCIENCE</a:t>
+              <a:t>SCIENCE</a:t>
             </a:r>
           </a:p>
         </p:txBody>
@@ -5830,7 +5959,7 @@
                 </a:solidFill>
                 <a:latin typeface="Frutiger"/>
               </a:rPr>
-              <a:t>Hong Kong rainfall, 1884–2025: annual peaks, the gaps between them, return periods.</a:t>
+              <a:t>Rainfall, Hong Kong 1884–2025: annual peaks, the gaps between them, return periods.</a:t>
             </a:r>
           </a:p>
           <a:p>
@@ -5849,7 +5978,7 @@
                 </a:solidFill>
                 <a:latin typeface="Frutiger"/>
               </a:rPr>
-              <a:t>Rhine and alpine rivers, 8 stations: flow duration, recession, the seasonal cycle.</a:t>
+              <a:t>Rivers, Rhine and alpine, 8 stations: flow duration, recession, the seasonal cycle.</a:t>
             </a:r>
           </a:p>
           <a:p>
@@ -5868,7 +5997,7 @@
                 </a:solidFill>
                 <a:latin typeface="Frutiger"/>
               </a:rPr>
-              <a:t>Measures what happened, and is never adjusted for artistic reasons.</a:t>
+              <a:t>Measures what happened, and is never changed to suit the design.</a:t>
             </a:r>
           </a:p>
         </p:txBody>
@@ -6015,7 +6144,7 @@
                 </a:solidFill>
                 <a:latin typeface="Frutiger"/>
               </a:rPr>
-              <a:t>Decides how the results should feel: how alarming, how heavy.</a:t>
+              <a:t>Decides how a result should feel: how alarming, how heavy.</a:t>
             </a:r>
           </a:p>
           <a:p>
@@ -6034,7 +6163,7 @@
                 </a:solidFill>
                 <a:latin typeface="Frutiger"/>
               </a:rPr>
-              <a:t>Currently kept separate from the measurements, so the feeling could be redesigned without changing any of the science.</a:t>
+              <a:t>Developed separately in Unity3D, for presentation and exhibition.</a:t>
             </a:r>
           </a:p>
           <a:p>
@@ -6053,7 +6182,7 @@
                 </a:solidFill>
                 <a:latin typeface="Frutiger"/>
               </a:rPr>
-              <a:t>Its output: valence and arousal.</a:t>
+              <a:t>Output: valence and arousal. Set by design judgement and checked against named historical events; not yet tested with viewers.</a:t>
             </a:r>
           </a:p>
         </p:txBody>
@@ -6212,14 +6341,14 @@
                 </a:solidFill>
                 <a:latin typeface="Frutiger"/>
               </a:rPr>
-              <a:t>Its one job so far, unsupervised: learn what a typical year looks like, then score how badly each year fits.</a:t>
+              <a:t>Unsupervised: learn what a typical year looks like for each record, then score how badly each year fits.</a:t>
             </a:r>
           </a:p>
         </p:txBody>
       </p:sp>
       <p:pic>
         <p:nvPicPr>
-          <p:cNvPr id="4" name="Picture 3" descr="anomaly_floods2.png"/>
+          <p:cNvPr id="4" name="Picture 3" descr="anomaly_ribbon.png"/>
           <p:cNvPicPr>
             <a:picLocks noChangeAspect="1"/>
           </p:cNvPicPr>
@@ -6234,7 +6363,7 @@
         <p:spPr>
           <a:xfrm>
             <a:off x="914400" y="2148840"/>
-            <a:ext cx="10362895" cy="3019046"/>
+            <a:ext cx="10362895" cy="2744587"/>
           </a:xfrm>
           <a:prstGeom prst="rect">
             <a:avLst/>
@@ -6249,7 +6378,7 @@
         </p:nvSpPr>
         <p:spPr>
           <a:xfrm>
-            <a:off x="914400" y="5230368"/>
+            <a:off x="914400" y="5120640"/>
             <a:ext cx="10362895" cy="365760"/>
           </a:xfrm>
           <a:prstGeom prst="rect">
@@ -6271,7 +6400,7 @@
                 </a:solidFill>
                 <a:latin typeface="Frutiger"/>
               </a:rPr>
-              <a:t>The highlighted bar is each station's highest-scoring year. </a:t>
+              <a:t>Outlined: each station's highest-scoring year, 1951–2020. </a:t>
             </a:r>
             <a:r>
               <a:rPr sz="1260" b="0" i="0">
@@ -6280,7 +6409,7 @@
                 </a:solidFill>
                 <a:latin typeface="Frutiger"/>
               </a:rPr>
-              <a:t>The model was never told these events existed.</a:t>
+              <a:t>The model was never told what happened in any of them.</a:t>
             </a:r>
           </a:p>
         </p:txBody>
@@ -6293,8 +6422,8 @@
         </p:nvSpPr>
         <p:spPr>
           <a:xfrm>
-            <a:off x="914400" y="5623560"/>
-            <a:ext cx="10362895" cy="457200"/>
+            <a:off x="914400" y="5577840"/>
+            <a:ext cx="10362895" cy="548640"/>
           </a:xfrm>
           <a:prstGeom prst="rect">
             <a:avLst/>
@@ -6306,6 +6435,25 @@
             <a:noAutofit/>
           </a:bodyPr>
           <a:lstStyle/>
+          <a:p>
+            <a:pPr algn="l">
+              <a:lnSpc>
+                <a:spcPct val="108000"/>
+              </a:lnSpc>
+              <a:spcAft>
+                <a:spcPts val="300"/>
+              </a:spcAft>
+            </a:pPr>
+            <a:r>
+              <a:rPr sz="1000" b="0" i="0">
+                <a:solidFill>
+                  <a:srgbClr val="5F6F78"/>
+                </a:solidFill>
+                <a:latin typeface="Frutiger"/>
+              </a:rPr>
+              <a:t>Method: PCA reconstruction error, one model per station. 1993: Christmas Rhine flood (Köln, Lobith). 2005: Alpine floods (Lustenau). 1972: a drought year in Issue 6.</a:t>
+            </a:r>
+          </a:p>
           <a:p>
             <a:pPr algn="l">
               <a:lnSpc>
@@ -6319,7 +6467,7 @@
                 </a:solidFill>
                 <a:latin typeface="Frutiger"/>
               </a:rPr>
-              <a:t>Method: PCA reconstruction error, fit separately per station on its own years. Events: Aug 2005 Alpine floods (22–23 Aug), May 1999 Swiss floods (Thun, 15 May), Christmas 1993 Rhine flood (Köln, 24 Dec).</a:t>
+              <a:t>Limit: it flags unusual combinations, not extremes. 1976 drought: 3rd of 70 years at Lustenau, 187th of 208 at Köln. 1995 Köln flood: 101st.</a:t>
             </a:r>
           </a:p>
         </p:txBody>
@@ -6409,9 +6557,33 @@
         <p:nvPr/>
       </p:nvGrpSpPr>
       <p:grpSpPr/>
-      <p:sp>
-        <p:nvSpPr>
-          <p:cNvPr id="2" name="TextBox 1"/>
+      <p:pic>
+        <p:nvPicPr>
+          <p:cNvPr id="2" name="Picture 1" descr="atmosphere.jpg"/>
+          <p:cNvPicPr>
+            <a:picLocks noChangeAspect="1"/>
+          </p:cNvPicPr>
+          <p:nvPr/>
+        </p:nvPicPr>
+        <p:blipFill>
+          <a:blip r:embed="rId3"/>
+          <a:stretch>
+            <a:fillRect/>
+          </a:stretch>
+        </p:blipFill>
+        <p:spPr>
+          <a:xfrm>
+            <a:off x="7223760" y="-548640"/>
+            <a:ext cx="8229600" cy="8229600"/>
+          </a:xfrm>
+          <a:prstGeom prst="rect">
+            <a:avLst/>
+          </a:prstGeom>
+        </p:spPr>
+      </p:pic>
+      <p:sp>
+        <p:nvSpPr>
+          <p:cNvPr id="3" name="TextBox 2"/>
           <p:cNvSpPr txBox="1"/>
           <p:nvPr/>
         </p:nvSpPr>
@@ -6450,14 +6622,14 @@
       </p:sp>
       <p:sp>
         <p:nvSpPr>
-          <p:cNvPr id="3" name="TextBox 2"/>
+          <p:cNvPr id="4" name="TextBox 3"/>
           <p:cNvSpPr txBox="1"/>
           <p:nvPr/>
         </p:nvSpPr>
         <p:spPr>
           <a:xfrm>
-            <a:off x="914400" y="2103120"/>
-            <a:ext cx="10362895" cy="1828800"/>
+            <a:off x="914400" y="2377440"/>
+            <a:ext cx="7863840" cy="1463040"/>
           </a:xfrm>
           <a:prstGeom prst="rect">
             <a:avLst/>
@@ -6476,26 +6648,35 @@
               </a:lnSpc>
             </a:pPr>
             <a:r>
-              <a:rPr sz="2180" b="0" i="0">
+              <a:rPr sz="2180" b="0" i="1">
                 <a:solidFill>
                   <a:srgbClr val="111A20"/>
                 </a:solidFill>
                 <a:latin typeface="Athelas"/>
               </a:rPr>
-              <a:t>Noéa connects machine intelligence to natural intelligence: a model learns the rhythm of a river or rainfall record and flags when it breaks.</a:t>
+              <a:t>Noéa</a:t>
+            </a:r>
+            <a:r>
+              <a:rPr sz="2180" b="0" i="0">
+                <a:solidFill>
+                  <a:srgbClr val="111A20"/>
+                </a:solidFill>
+                <a:latin typeface="Athelas"/>
+              </a:rPr>
+              <a:t> links machine intelligence to natural intelligence.</a:t>
             </a:r>
           </a:p>
         </p:txBody>
       </p:sp>
       <p:cxnSp>
         <p:nvCxnSpPr>
-          <p:cNvPr id="4" name="Connector 3"/>
+          <p:cNvPr id="5" name="Connector 4"/>
           <p:cNvCxnSpPr/>
           <p:nvPr/>
         </p:nvCxnSpPr>
         <p:spPr>
           <a:xfrm>
-            <a:off x="914400" y="4160520"/>
+            <a:off x="914400" y="3794760"/>
             <a:ext cx="1097280" cy="0"/>
           </a:xfrm>
           <a:prstGeom prst="line">
@@ -6524,14 +6705,14 @@
       </p:cxnSp>
       <p:sp>
         <p:nvSpPr>
-          <p:cNvPr id="5" name="TextBox 4"/>
+          <p:cNvPr id="6" name="TextBox 5"/>
           <p:cNvSpPr txBox="1"/>
           <p:nvPr/>
         </p:nvSpPr>
         <p:spPr>
           <a:xfrm>
-            <a:off x="914400" y="4389120"/>
-            <a:ext cx="10362895" cy="1280160"/>
+            <a:off x="914400" y="4023360"/>
+            <a:ext cx="7863840" cy="1097280"/>
           </a:xfrm>
           <a:prstGeom prst="rect">
             <a:avLst/>
@@ -6556,14 +6737,14 @@
                 </a:solidFill>
                 <a:latin typeface="Athelas"/>
               </a:rPr>
-              <a:t>How people respond to that now has to be tested in human labs, with HCI methods. That is the research.</a:t>
-            </a:r>
-          </a:p>
-        </p:txBody>
-      </p:sp>
-      <p:sp>
-        <p:nvSpPr>
-          <p:cNvPr id="6" name="TextBox 5"/>
+              <a:t>Do people feel what it flags? That is the research.</a:t>
+            </a:r>
+          </a:p>
+        </p:txBody>
+      </p:sp>
+      <p:sp>
+        <p:nvSpPr>
+          <p:cNvPr id="7" name="TextBox 6"/>
           <p:cNvSpPr txBox="1"/>
           <p:nvPr/>
         </p:nvSpPr>
@@ -6598,14 +6779,14 @@
       </p:sp>
       <p:pic>
         <p:nvPicPr>
-          <p:cNvPr id="7" name="Picture 6" descr="logo.png"/>
+          <p:cNvPr id="8" name="Picture 7" descr="logo.png"/>
           <p:cNvPicPr>
             <a:picLocks noChangeAspect="1"/>
           </p:cNvPicPr>
           <p:nvPr/>
         </p:nvPicPr>
         <p:blipFill>
-          <a:blip r:embed="rId3"/>
+          <a:blip r:embed="rId4"/>
           <a:stretch>
             <a:fillRect/>
           </a:stretch>
@@ -6622,7 +6803,7 @@
       </p:pic>
       <p:sp>
         <p:nvSpPr>
-          <p:cNvPr id="8" name="TextBox 7"/>
+          <p:cNvPr id="9" name="TextBox 8"/>
           <p:cNvSpPr txBox="1"/>
           <p:nvPr/>
         </p:nvSpPr>

</xml_diff>